<commit_message>
PPT con las fotos del equipo: QGate_oficial.pptx tal cual y QGate_final.pptx
QGate_final.pptx usa la portada y el cierre con fotos de QGate_oficial.pptx y las slides de contenido
corregidas (semillas con solver exacto, azar calificado). PDF incluido; el README apunta a esta versión.

Co-Authored-By: Claude Opus 5.5 <noreply@anthropic.com>
</commit_message>
<xml_diff>
--- a/entrega/QGate_oficial.pptx
+++ b/entrega/QGate_oficial.pptx
@@ -1,42 +1,37 @@
 
 <file path=ppt/presentation.xml><?xml version="1.0" encoding="utf-8"?>
-<p:presentation xmlns:a="http://schemas.openxmlformats.org/drawingml/2006/main" xmlns:r="http://schemas.openxmlformats.org/officeDocument/2006/relationships" xmlns:p="http://schemas.openxmlformats.org/presentationml/2006/main" saveSubsetFonts="1" embedTrueTypeFonts="true">
+<p:presentation xmlns:a="http://schemas.openxmlformats.org/drawingml/2006/main" xmlns:r="http://schemas.openxmlformats.org/officeDocument/2006/relationships" xmlns:p="http://schemas.openxmlformats.org/presentationml/2006/main" embedTrueTypeFonts="1" saveSubsetFonts="1">
   <p:sldMasterIdLst>
     <p:sldMasterId id="2147483648" r:id="rId1"/>
   </p:sldMasterIdLst>
+  <p:notesMasterIdLst>
+    <p:notesMasterId r:id="rId11"/>
+  </p:notesMasterIdLst>
   <p:sldIdLst>
-    <p:sldId id="256" r:id="rId6"/>
-    <p:sldId id="264" r:id="rId12"/>
-    <p:sldId id="265" r:id="rId10"/>
-    <p:sldId id="266" r:id="rId9"/>
-    <p:sldId id="267" r:id="rId8"/>
+    <p:sldId id="256" r:id="rId2"/>
+    <p:sldId id="264" r:id="rId3"/>
+    <p:sldId id="265" r:id="rId4"/>
+    <p:sldId id="266" r:id="rId5"/>
+    <p:sldId id="267" r:id="rId6"/>
     <p:sldId id="268" r:id="rId7"/>
-    <p:sldId id="269" r:id="rId19"/>
-    <p:sldId id="270" r:id="rId20"/>
-    <p:sldId id="263" r:id="rId13"/>
+    <p:sldId id="269" r:id="rId8"/>
+    <p:sldId id="270" r:id="rId9"/>
+    <p:sldId id="263" r:id="rId10"/>
   </p:sldIdLst>
   <p:sldSz cx="18288000" cy="10287000"/>
   <p:notesSz cx="6858000" cy="9144000"/>
   <p:embeddedFontLst>
     <p:embeddedFont>
-      <p:font typeface="Fira Sans Light" charset="1" panose="020B0403050000020004"/>
-      <p:regular r:id="rId14"/>
+      <p:font typeface="Fira Sans" panose="020F0502020204030204" pitchFamily="34" charset="0"/>
+      <p:regular r:id="rId12"/>
     </p:embeddedFont>
     <p:embeddedFont>
-      <p:font typeface="IBM Plex Sans" charset="1" panose="020B0503050203000203"/>
-      <p:regular r:id="rId15"/>
+      <p:font typeface="Fira Sans Light" panose="020B0403050000020004" pitchFamily="34" charset="0"/>
+      <p:regular r:id="rId13"/>
     </p:embeddedFont>
     <p:embeddedFont>
-      <p:font typeface="IBM Plex Sans Bold" charset="1" panose="020B0803050203000203"/>
-      <p:regular r:id="rId16"/>
-    </p:embeddedFont>
-    <p:embeddedFont>
-      <p:font typeface="IBM Plex Sans Bold Italics" charset="1" panose="020B0803050203000203"/>
-      <p:regular r:id="rId17"/>
-    </p:embeddedFont>
-    <p:embeddedFont>
-      <p:font typeface="Fira Sans" charset="1" panose="020B0503050000020004"/>
-      <p:regular r:id="rId18"/>
+      <p:font typeface="IBM Plex Sans" panose="020B0503050203000203" pitchFamily="34" charset="0"/>
+      <p:regular r:id="rId14"/>
     </p:embeddedFont>
   </p:embeddedFontLst>
   <p:defaultTextStyle>
@@ -134,11 +129,27 @@
       </a:defRPr>
     </a:lvl9pPr>
   </p:defaultTextStyle>
+  <p:extLst>
+    <p:ext uri="{EFAFB233-063F-42B5-8137-9DF3F51BA10A}">
+      <p15:sldGuideLst xmlns:p15="http://schemas.microsoft.com/office/powerpoint/2012/main">
+        <p15:guide id="1" orient="horz" pos="2160">
+          <p15:clr>
+            <a:srgbClr val="A4A3A4"/>
+          </p15:clr>
+        </p15:guide>
+        <p15:guide id="2" pos="2880">
+          <p15:clr>
+            <a:srgbClr val="A4A3A4"/>
+          </p15:clr>
+        </p15:guide>
+      </p15:sldGuideLst>
+    </p:ext>
+  </p:extLst>
 </p:presentation>
 </file>
 
 <file path=ppt/notesMasters/notesMaster1.xml><?xml version="1.0" encoding="utf-8"?>
-<p:notesMaster xmlns:a="http://schemas.openxmlformats.org/drawingml/2006/main" xmlns:p="http://schemas.openxmlformats.org/presentationml/2006/main" xmlns:r="http://schemas.openxmlformats.org/officeDocument/2006/relationships">
+<p:notesMaster xmlns:a="http://schemas.openxmlformats.org/drawingml/2006/main" xmlns:r="http://schemas.openxmlformats.org/officeDocument/2006/relationships" xmlns:p="http://schemas.openxmlformats.org/presentationml/2006/main">
   <p:cSld>
     <p:bg>
       <p:bgRef idx="1001">
@@ -161,7 +172,7 @@
       </p:grpSpPr>
       <p:sp>
         <p:nvSpPr>
-          <p:cNvPr id="2" name="Header Placeholder 1"/>
+          <p:cNvPr id="2" name="Marcador de encabezado 1"/>
           <p:cNvSpPr>
             <a:spLocks noGrp="1"/>
           </p:cNvSpPr>
@@ -172,7 +183,7 @@
         <p:spPr>
           <a:xfrm>
             <a:off x="0" y="0"/>
-            <a:ext cx="2971800" cy="457200"/>
+            <a:ext cx="2971800" cy="458788"/>
           </a:xfrm>
           <a:prstGeom prst="rect">
             <a:avLst/>
@@ -186,13 +197,13 @@
             </a:lvl1pPr>
           </a:lstStyle>
           <a:p>
-            <a:endParaRPr lang="en-US"/>
-          </a:p>
-        </p:txBody>
-      </p:sp>
-      <p:sp>
-        <p:nvSpPr>
-          <p:cNvPr id="3" name="Date Placeholder 2"/>
+            <a:endParaRPr lang="es-PE"/>
+          </a:p>
+        </p:txBody>
+      </p:sp>
+      <p:sp>
+        <p:nvSpPr>
+          <p:cNvPr id="3" name="Marcador de fecha 2"/>
           <p:cNvSpPr>
             <a:spLocks noGrp="1"/>
           </p:cNvSpPr>
@@ -203,7 +214,7 @@
         <p:spPr>
           <a:xfrm>
             <a:off x="3884613" y="0"/>
-            <a:ext cx="2971800" cy="457200"/>
+            <a:ext cx="2971800" cy="458788"/>
           </a:xfrm>
           <a:prstGeom prst="rect">
             <a:avLst/>
@@ -217,17 +228,17 @@
             </a:lvl1pPr>
           </a:lstStyle>
           <a:p>
-            <a:fld id="{0F89C1C7-3DCD-1040-A9CF-14679D8B5DDD}" type="datetimeFigureOut">
-              <a:rPr lang="en-US" smtClean="0"/>
-              <a:t>10/17/16</a:t>
+            <a:fld id="{93062BDF-F0B5-45E3-AD5B-41D0B891B176}" type="datetimeFigureOut">
+              <a:rPr lang="es-PE" smtClean="0"/>
+              <a:t>24/10/2026</a:t>
             </a:fld>
-            <a:endParaRPr lang="en-US"/>
-          </a:p>
-        </p:txBody>
-      </p:sp>
-      <p:sp>
-        <p:nvSpPr>
-          <p:cNvPr id="4" name="Slide Image Placeholder 3"/>
+            <a:endParaRPr lang="es-PE"/>
+          </a:p>
+        </p:txBody>
+      </p:sp>
+      <p:sp>
+        <p:nvSpPr>
+          <p:cNvPr id="4" name="Marcador de imagen de diapositiva 3"/>
           <p:cNvSpPr>
             <a:spLocks noGrp="1" noRot="1" noChangeAspect="1"/>
           </p:cNvSpPr>
@@ -237,8 +248,8 @@
         </p:nvSpPr>
         <p:spPr>
           <a:xfrm>
-            <a:off x="1143000" y="685800"/>
-            <a:ext cx="4572000" cy="3429000"/>
+            <a:off x="685800" y="1143000"/>
+            <a:ext cx="5486400" cy="3086100"/>
           </a:xfrm>
           <a:prstGeom prst="rect">
             <a:avLst/>
@@ -254,13 +265,13 @@
           <a:bodyPr vert="horz" lIns="91440" tIns="45720" rIns="91440" bIns="45720" rtlCol="0" anchor="ctr"/>
           <a:lstStyle/>
           <a:p>
-            <a:endParaRPr lang="en-US"/>
-          </a:p>
-        </p:txBody>
-      </p:sp>
-      <p:sp>
-        <p:nvSpPr>
-          <p:cNvPr id="5" name="Notes Placeholder 4"/>
+            <a:endParaRPr lang="es-PE"/>
+          </a:p>
+        </p:txBody>
+      </p:sp>
+      <p:sp>
+        <p:nvSpPr>
+          <p:cNvPr id="5" name="Marcador de notas 4"/>
           <p:cNvSpPr>
             <a:spLocks noGrp="1"/>
           </p:cNvSpPr>
@@ -270,8 +281,8 @@
         </p:nvSpPr>
         <p:spPr>
           <a:xfrm>
-            <a:off x="685800" y="4343400"/>
-            <a:ext cx="5486400" cy="4114800"/>
+            <a:off x="685800" y="4400550"/>
+            <a:ext cx="5486400" cy="3600450"/>
           </a:xfrm>
           <a:prstGeom prst="rect">
             <a:avLst/>
@@ -283,44 +294,44 @@
           <a:p>
             <a:pPr lvl="0"/>
             <a:r>
-              <a:rPr lang="en-US" smtClean="0"/>
-              <a:t>Click to edit Master text styles</a:t>
+              <a:rPr lang="es-ES"/>
+              <a:t>Haga clic para modificar los estilos de texto del patrón</a:t>
             </a:r>
           </a:p>
           <a:p>
             <a:pPr lvl="1"/>
             <a:r>
-              <a:rPr lang="en-US" smtClean="0"/>
-              <a:t>Second level</a:t>
+              <a:rPr lang="es-ES"/>
+              <a:t>Segundo nivel</a:t>
             </a:r>
           </a:p>
           <a:p>
             <a:pPr lvl="2"/>
             <a:r>
-              <a:rPr lang="en-US" smtClean="0"/>
-              <a:t>Third level</a:t>
+              <a:rPr lang="es-ES"/>
+              <a:t>Tercer nivel</a:t>
             </a:r>
           </a:p>
           <a:p>
             <a:pPr lvl="3"/>
             <a:r>
-              <a:rPr lang="en-US" smtClean="0"/>
-              <a:t>Fourth level</a:t>
+              <a:rPr lang="es-ES"/>
+              <a:t>Cuarto nivel</a:t>
             </a:r>
           </a:p>
           <a:p>
             <a:pPr lvl="4"/>
             <a:r>
-              <a:rPr lang="en-US" smtClean="0"/>
-              <a:t>Fifth level</a:t>
-            </a:r>
-            <a:endParaRPr lang="en-US"/>
-          </a:p>
-        </p:txBody>
-      </p:sp>
-      <p:sp>
-        <p:nvSpPr>
-          <p:cNvPr id="6" name="Footer Placeholder 5"/>
+              <a:rPr lang="es-ES"/>
+              <a:t>Quinto nivel</a:t>
+            </a:r>
+            <a:endParaRPr lang="es-PE"/>
+          </a:p>
+        </p:txBody>
+      </p:sp>
+      <p:sp>
+        <p:nvSpPr>
+          <p:cNvPr id="6" name="Marcador de pie de página 5"/>
           <p:cNvSpPr>
             <a:spLocks noGrp="1"/>
           </p:cNvSpPr>
@@ -331,7 +342,7 @@
         <p:spPr>
           <a:xfrm>
             <a:off x="0" y="8685213"/>
-            <a:ext cx="2971800" cy="457200"/>
+            <a:ext cx="2971800" cy="458787"/>
           </a:xfrm>
           <a:prstGeom prst="rect">
             <a:avLst/>
@@ -345,13 +356,13 @@
             </a:lvl1pPr>
           </a:lstStyle>
           <a:p>
-            <a:endParaRPr lang="en-US"/>
-          </a:p>
-        </p:txBody>
-      </p:sp>
-      <p:sp>
-        <p:nvSpPr>
-          <p:cNvPr id="7" name="Slide Number Placeholder 6"/>
+            <a:endParaRPr lang="es-PE"/>
+          </a:p>
+        </p:txBody>
+      </p:sp>
+      <p:sp>
+        <p:nvSpPr>
+          <p:cNvPr id="7" name="Marcador de número de diapositiva 6"/>
           <p:cNvSpPr>
             <a:spLocks noGrp="1"/>
           </p:cNvSpPr>
@@ -362,7 +373,7 @@
         <p:spPr>
           <a:xfrm>
             <a:off x="3884613" y="8685213"/>
-            <a:ext cx="2971800" cy="457200"/>
+            <a:ext cx="2971800" cy="458787"/>
           </a:xfrm>
           <a:prstGeom prst="rect">
             <a:avLst/>
@@ -376,24 +387,24 @@
             </a:lvl1pPr>
           </a:lstStyle>
           <a:p>
-            <a:fld id="{BB5E49A5-4136-284D-997B-48E1D791AD67}" type="slidenum">
-              <a:rPr lang="en-US" smtClean="0"/>
-              <a:t>‹#›</a:t>
+            <a:fld id="{38C994C2-6660-4B45-B4D5-A4B56F412CD1}" type="slidenum">
+              <a:rPr lang="es-PE" smtClean="0"/>
+              <a:t>‹Nº›</a:t>
             </a:fld>
-            <a:endParaRPr lang="en-US"/>
+            <a:endParaRPr lang="es-PE"/>
           </a:p>
         </p:txBody>
       </p:sp>
     </p:spTree>
     <p:extLst>
       <p:ext uri="{BB962C8B-B14F-4D97-AF65-F5344CB8AC3E}">
-        <p14:creationId xmlns:p14="http://schemas.microsoft.com/office/powerpoint/2010/main" val="2623252185"/>
+        <p14:creationId xmlns:p14="http://schemas.microsoft.com/office/powerpoint/2010/main" val="1168299772"/>
       </p:ext>
     </p:extLst>
   </p:cSld>
   <p:clrMap bg1="lt1" tx1="dk1" bg2="lt2" tx2="dk2" accent1="accent1" accent2="accent2" accent3="accent3" accent4="accent4" accent5="accent5" accent6="accent6" hlink="hlink" folHlink="folHlink"/>
   <p:notesStyle>
-    <a:lvl1pPr marL="0" algn="l" defTabSz="457200" rtl="0" eaLnBrk="1" latinLnBrk="0" hangingPunct="1">
+    <a:lvl1pPr marL="0" algn="l" defTabSz="914400" rtl="0" eaLnBrk="1" latinLnBrk="0" hangingPunct="1">
       <a:defRPr sz="1200" kern="1200">
         <a:solidFill>
           <a:schemeClr val="tx1"/>
@@ -403,7 +414,7 @@
         <a:cs typeface="+mn-cs"/>
       </a:defRPr>
     </a:lvl1pPr>
-    <a:lvl2pPr marL="457200" algn="l" defTabSz="457200" rtl="0" eaLnBrk="1" latinLnBrk="0" hangingPunct="1">
+    <a:lvl2pPr marL="457200" algn="l" defTabSz="914400" rtl="0" eaLnBrk="1" latinLnBrk="0" hangingPunct="1">
       <a:defRPr sz="1200" kern="1200">
         <a:solidFill>
           <a:schemeClr val="tx1"/>
@@ -413,7 +424,7 @@
         <a:cs typeface="+mn-cs"/>
       </a:defRPr>
     </a:lvl2pPr>
-    <a:lvl3pPr marL="914400" algn="l" defTabSz="457200" rtl="0" eaLnBrk="1" latinLnBrk="0" hangingPunct="1">
+    <a:lvl3pPr marL="914400" algn="l" defTabSz="914400" rtl="0" eaLnBrk="1" latinLnBrk="0" hangingPunct="1">
       <a:defRPr sz="1200" kern="1200">
         <a:solidFill>
           <a:schemeClr val="tx1"/>
@@ -423,7 +434,7 @@
         <a:cs typeface="+mn-cs"/>
       </a:defRPr>
     </a:lvl3pPr>
-    <a:lvl4pPr marL="1371600" algn="l" defTabSz="457200" rtl="0" eaLnBrk="1" latinLnBrk="0" hangingPunct="1">
+    <a:lvl4pPr marL="1371600" algn="l" defTabSz="914400" rtl="0" eaLnBrk="1" latinLnBrk="0" hangingPunct="1">
       <a:defRPr sz="1200" kern="1200">
         <a:solidFill>
           <a:schemeClr val="tx1"/>
@@ -433,7 +444,7 @@
         <a:cs typeface="+mn-cs"/>
       </a:defRPr>
     </a:lvl4pPr>
-    <a:lvl5pPr marL="1828800" algn="l" defTabSz="457200" rtl="0" eaLnBrk="1" latinLnBrk="0" hangingPunct="1">
+    <a:lvl5pPr marL="1828800" algn="l" defTabSz="914400" rtl="0" eaLnBrk="1" latinLnBrk="0" hangingPunct="1">
       <a:defRPr sz="1200" kern="1200">
         <a:solidFill>
           <a:schemeClr val="tx1"/>
@@ -443,7 +454,7 @@
         <a:cs typeface="+mn-cs"/>
       </a:defRPr>
     </a:lvl5pPr>
-    <a:lvl6pPr marL="2286000" algn="l" defTabSz="457200" rtl="0" eaLnBrk="1" latinLnBrk="0" hangingPunct="1">
+    <a:lvl6pPr marL="2286000" algn="l" defTabSz="914400" rtl="0" eaLnBrk="1" latinLnBrk="0" hangingPunct="1">
       <a:defRPr sz="1200" kern="1200">
         <a:solidFill>
           <a:schemeClr val="tx1"/>
@@ -453,7 +464,7 @@
         <a:cs typeface="+mn-cs"/>
       </a:defRPr>
     </a:lvl6pPr>
-    <a:lvl7pPr marL="2743200" algn="l" defTabSz="457200" rtl="0" eaLnBrk="1" latinLnBrk="0" hangingPunct="1">
+    <a:lvl7pPr marL="2743200" algn="l" defTabSz="914400" rtl="0" eaLnBrk="1" latinLnBrk="0" hangingPunct="1">
       <a:defRPr sz="1200" kern="1200">
         <a:solidFill>
           <a:schemeClr val="tx1"/>
@@ -463,7 +474,7 @@
         <a:cs typeface="+mn-cs"/>
       </a:defRPr>
     </a:lvl7pPr>
-    <a:lvl8pPr marL="3200400" algn="l" defTabSz="457200" rtl="0" eaLnBrk="1" latinLnBrk="0" hangingPunct="1">
+    <a:lvl8pPr marL="3200400" algn="l" defTabSz="914400" rtl="0" eaLnBrk="1" latinLnBrk="0" hangingPunct="1">
       <a:defRPr sz="1200" kern="1200">
         <a:solidFill>
           <a:schemeClr val="tx1"/>
@@ -473,7 +484,7 @@
         <a:cs typeface="+mn-cs"/>
       </a:defRPr>
     </a:lvl8pPr>
-    <a:lvl9pPr marL="3657600" algn="l" defTabSz="457200" rtl="0" eaLnBrk="1" latinLnBrk="0" hangingPunct="1">
+    <a:lvl9pPr marL="3657600" algn="l" defTabSz="914400" rtl="0" eaLnBrk="1" latinLnBrk="0" hangingPunct="1">
       <a:defRPr sz="1200" kern="1200">
         <a:solidFill>
           <a:schemeClr val="tx1"/>
@@ -488,7 +499,7 @@
 </file>
 
 <file path=ppt/notesSlides/notesSlide1.xml><?xml version="1.0" encoding="utf-8"?>
-<p:notes xmlns:a="http://schemas.openxmlformats.org/drawingml/2006/main" xmlns:p="http://schemas.openxmlformats.org/presentationml/2006/main" xmlns:r="http://schemas.openxmlformats.org/officeDocument/2006/relationships">
+<p:notes xmlns:a="http://schemas.openxmlformats.org/drawingml/2006/main" xmlns:r="http://schemas.openxmlformats.org/officeDocument/2006/relationships" xmlns:p="http://schemas.openxmlformats.org/presentationml/2006/main">
   <p:cSld>
     <p:spTree>
       <p:nvGrpSpPr>
@@ -508,7 +519,7 @@
         <p:nvSpPr>
           <p:cNvPr id="2" name="Slide Image Placeholder 1"/>
           <p:cNvSpPr>
-            <a:spLocks noGrp="1"/>
+            <a:spLocks noGrp="1" noRot="1" noChangeAspect="1"/>
           </p:cNvSpPr>
           <p:nvPr>
             <p:ph type="sldImg" idx="2"/>
@@ -523,7 +534,7 @@
             <a:spLocks noGrp="1"/>
           </p:cNvSpPr>
           <p:nvPr>
-            <p:ph type="body" idx="3" sz="quarter"/>
+            <p:ph type="body" sz="quarter" idx="3"/>
           </p:nvPr>
         </p:nvSpPr>
         <p:spPr/>
@@ -544,7 +555,7 @@
             <a:spLocks noGrp="1"/>
           </p:cNvSpPr>
           <p:nvPr>
-            <p:ph type="sldNum" idx="5" sz="quarter"/>
+            <p:ph type="sldNum" sz="quarter" idx="5"/>
           </p:nvPr>
         </p:nvSpPr>
         <p:spPr/>
@@ -558,7 +569,7 @@
 </file>
 
 <file path=ppt/notesSlides/notesSlide2.xml><?xml version="1.0" encoding="utf-8"?>
-<p:notes xmlns:a="http://schemas.openxmlformats.org/drawingml/2006/main" xmlns:p="http://schemas.openxmlformats.org/presentationml/2006/main" xmlns:r="http://schemas.openxmlformats.org/officeDocument/2006/relationships">
+<p:notes xmlns:a="http://schemas.openxmlformats.org/drawingml/2006/main" xmlns:r="http://schemas.openxmlformats.org/officeDocument/2006/relationships" xmlns:p="http://schemas.openxmlformats.org/presentationml/2006/main">
   <p:cSld>
     <p:spTree>
       <p:nvGrpSpPr>
@@ -578,7 +589,7 @@
         <p:nvSpPr>
           <p:cNvPr id="2" name="Slide Image Placeholder 1"/>
           <p:cNvSpPr>
-            <a:spLocks noGrp="1"/>
+            <a:spLocks noGrp="1" noRot="1" noChangeAspect="1"/>
           </p:cNvSpPr>
           <p:nvPr>
             <p:ph type="sldImg" idx="2"/>
@@ -593,7 +604,7 @@
             <a:spLocks noGrp="1"/>
           </p:cNvSpPr>
           <p:nvPr>
-            <p:ph type="body" idx="3" sz="quarter"/>
+            <p:ph type="body" sz="quarter" idx="3"/>
           </p:nvPr>
         </p:nvSpPr>
         <p:spPr/>
@@ -614,7 +625,7 @@
             <a:spLocks noGrp="1"/>
           </p:cNvSpPr>
           <p:nvPr>
-            <p:ph type="sldNum" idx="5" sz="quarter"/>
+            <p:ph type="sldNum" sz="quarter" idx="5"/>
           </p:nvPr>
         </p:nvSpPr>
         <p:spPr/>
@@ -628,7 +639,7 @@
 </file>
 
 <file path=ppt/notesSlides/notesSlide3.xml><?xml version="1.0" encoding="utf-8"?>
-<p:notes xmlns:a="http://schemas.openxmlformats.org/drawingml/2006/main" xmlns:p="http://schemas.openxmlformats.org/presentationml/2006/main" xmlns:r="http://schemas.openxmlformats.org/officeDocument/2006/relationships">
+<p:notes xmlns:a="http://schemas.openxmlformats.org/drawingml/2006/main" xmlns:r="http://schemas.openxmlformats.org/officeDocument/2006/relationships" xmlns:p="http://schemas.openxmlformats.org/presentationml/2006/main">
   <p:cSld>
     <p:spTree>
       <p:nvGrpSpPr>
@@ -648,7 +659,7 @@
         <p:nvSpPr>
           <p:cNvPr id="2" name="Slide Image Placeholder 1"/>
           <p:cNvSpPr>
-            <a:spLocks noGrp="1"/>
+            <a:spLocks noGrp="1" noRot="1" noChangeAspect="1"/>
           </p:cNvSpPr>
           <p:nvPr>
             <p:ph type="sldImg" idx="2"/>
@@ -663,7 +674,7 @@
             <a:spLocks noGrp="1"/>
           </p:cNvSpPr>
           <p:nvPr>
-            <p:ph type="body" idx="3" sz="quarter"/>
+            <p:ph type="body" sz="quarter" idx="3"/>
           </p:nvPr>
         </p:nvSpPr>
         <p:spPr/>
@@ -684,7 +695,7 @@
             <a:spLocks noGrp="1"/>
           </p:cNvSpPr>
           <p:nvPr>
-            <p:ph type="sldNum" idx="5" sz="quarter"/>
+            <p:ph type="sldNum" sz="quarter" idx="5"/>
           </p:nvPr>
         </p:nvSpPr>
         <p:spPr/>
@@ -698,7 +709,7 @@
 </file>
 
 <file path=ppt/notesSlides/notesSlide4.xml><?xml version="1.0" encoding="utf-8"?>
-<p:notes xmlns:a="http://schemas.openxmlformats.org/drawingml/2006/main" xmlns:p="http://schemas.openxmlformats.org/presentationml/2006/main" xmlns:r="http://schemas.openxmlformats.org/officeDocument/2006/relationships">
+<p:notes xmlns:a="http://schemas.openxmlformats.org/drawingml/2006/main" xmlns:r="http://schemas.openxmlformats.org/officeDocument/2006/relationships" xmlns:p="http://schemas.openxmlformats.org/presentationml/2006/main">
   <p:cSld>
     <p:spTree>
       <p:nvGrpSpPr>
@@ -718,7 +729,7 @@
         <p:nvSpPr>
           <p:cNvPr id="2" name="Slide Image Placeholder 1"/>
           <p:cNvSpPr>
-            <a:spLocks noGrp="1"/>
+            <a:spLocks noGrp="1" noRot="1" noChangeAspect="1"/>
           </p:cNvSpPr>
           <p:nvPr>
             <p:ph type="sldImg" idx="2"/>
@@ -733,7 +744,7 @@
             <a:spLocks noGrp="1"/>
           </p:cNvSpPr>
           <p:nvPr>
-            <p:ph type="body" idx="3" sz="quarter"/>
+            <p:ph type="body" sz="quarter" idx="3"/>
           </p:nvPr>
         </p:nvSpPr>
         <p:spPr/>
@@ -754,7 +765,7 @@
             <a:spLocks noGrp="1"/>
           </p:cNvSpPr>
           <p:nvPr>
-            <p:ph type="sldNum" idx="5" sz="quarter"/>
+            <p:ph type="sldNum" sz="quarter" idx="5"/>
           </p:nvPr>
         </p:nvSpPr>
         <p:spPr/>
@@ -768,7 +779,7 @@
 </file>
 
 <file path=ppt/notesSlides/notesSlide5.xml><?xml version="1.0" encoding="utf-8"?>
-<p:notes xmlns:a="http://schemas.openxmlformats.org/drawingml/2006/main" xmlns:p="http://schemas.openxmlformats.org/presentationml/2006/main" xmlns:r="http://schemas.openxmlformats.org/officeDocument/2006/relationships">
+<p:notes xmlns:a="http://schemas.openxmlformats.org/drawingml/2006/main" xmlns:r="http://schemas.openxmlformats.org/officeDocument/2006/relationships" xmlns:p="http://schemas.openxmlformats.org/presentationml/2006/main">
   <p:cSld>
     <p:spTree>
       <p:nvGrpSpPr>
@@ -788,7 +799,7 @@
         <p:nvSpPr>
           <p:cNvPr id="2" name="Slide Image Placeholder 1"/>
           <p:cNvSpPr>
-            <a:spLocks noGrp="1"/>
+            <a:spLocks noGrp="1" noRot="1" noChangeAspect="1"/>
           </p:cNvSpPr>
           <p:nvPr>
             <p:ph type="sldImg" idx="2"/>
@@ -803,7 +814,7 @@
             <a:spLocks noGrp="1"/>
           </p:cNvSpPr>
           <p:nvPr>
-            <p:ph type="body" idx="3" sz="quarter"/>
+            <p:ph type="body" sz="quarter" idx="3"/>
           </p:nvPr>
         </p:nvSpPr>
         <p:spPr/>
@@ -824,7 +835,7 @@
             <a:spLocks noGrp="1"/>
           </p:cNvSpPr>
           <p:nvPr>
-            <p:ph type="sldNum" idx="5" sz="quarter"/>
+            <p:ph type="sldNum" sz="quarter" idx="5"/>
           </p:nvPr>
         </p:nvSpPr>
         <p:spPr/>
@@ -838,7 +849,7 @@
 </file>
 
 <file path=ppt/notesSlides/notesSlide6.xml><?xml version="1.0" encoding="utf-8"?>
-<p:notes xmlns:a="http://schemas.openxmlformats.org/drawingml/2006/main" xmlns:p="http://schemas.openxmlformats.org/presentationml/2006/main" xmlns:r="http://schemas.openxmlformats.org/officeDocument/2006/relationships">
+<p:notes xmlns:a="http://schemas.openxmlformats.org/drawingml/2006/main" xmlns:r="http://schemas.openxmlformats.org/officeDocument/2006/relationships" xmlns:p="http://schemas.openxmlformats.org/presentationml/2006/main">
   <p:cSld>
     <p:spTree>
       <p:nvGrpSpPr>
@@ -858,7 +869,7 @@
         <p:nvSpPr>
           <p:cNvPr id="2" name="Slide Image Placeholder 1"/>
           <p:cNvSpPr>
-            <a:spLocks noGrp="1"/>
+            <a:spLocks noGrp="1" noRot="1" noChangeAspect="1"/>
           </p:cNvSpPr>
           <p:nvPr>
             <p:ph type="sldImg" idx="2"/>
@@ -873,7 +884,7 @@
             <a:spLocks noGrp="1"/>
           </p:cNvSpPr>
           <p:nvPr>
-            <p:ph type="body" idx="3" sz="quarter"/>
+            <p:ph type="body" sz="quarter" idx="3"/>
           </p:nvPr>
         </p:nvSpPr>
         <p:spPr/>
@@ -894,7 +905,7 @@
             <a:spLocks noGrp="1"/>
           </p:cNvSpPr>
           <p:nvPr>
-            <p:ph type="sldNum" idx="5" sz="quarter"/>
+            <p:ph type="sldNum" sz="quarter" idx="5"/>
           </p:nvPr>
         </p:nvSpPr>
         <p:spPr/>
@@ -908,7 +919,7 @@
 </file>
 
 <file path=ppt/notesSlides/notesSlide7.xml><?xml version="1.0" encoding="utf-8"?>
-<p:notes xmlns:a="http://schemas.openxmlformats.org/drawingml/2006/main" xmlns:p="http://schemas.openxmlformats.org/presentationml/2006/main" xmlns:r="http://schemas.openxmlformats.org/officeDocument/2006/relationships">
+<p:notes xmlns:a="http://schemas.openxmlformats.org/drawingml/2006/main" xmlns:r="http://schemas.openxmlformats.org/officeDocument/2006/relationships" xmlns:p="http://schemas.openxmlformats.org/presentationml/2006/main">
   <p:cSld>
     <p:spTree>
       <p:nvGrpSpPr>
@@ -928,7 +939,7 @@
         <p:nvSpPr>
           <p:cNvPr id="2" name="Slide Image Placeholder 1"/>
           <p:cNvSpPr>
-            <a:spLocks noGrp="1"/>
+            <a:spLocks noGrp="1" noRot="1" noChangeAspect="1"/>
           </p:cNvSpPr>
           <p:nvPr>
             <p:ph type="sldImg" idx="2"/>
@@ -943,7 +954,7 @@
             <a:spLocks noGrp="1"/>
           </p:cNvSpPr>
           <p:nvPr>
-            <p:ph type="body" idx="3" sz="quarter"/>
+            <p:ph type="body" sz="quarter" idx="3"/>
           </p:nvPr>
         </p:nvSpPr>
         <p:spPr/>
@@ -964,7 +975,7 @@
             <a:spLocks noGrp="1"/>
           </p:cNvSpPr>
           <p:nvPr>
-            <p:ph type="sldNum" idx="5" sz="quarter"/>
+            <p:ph type="sldNum" sz="quarter" idx="5"/>
           </p:nvPr>
         </p:nvSpPr>
         <p:spPr/>
@@ -1015,10 +1026,9 @@
           <a:lstStyle/>
           <a:p>
             <a:r>
-              <a:rPr lang="en-US" smtClean="0"/>
+              <a:rPr lang="en-US"/>
               <a:t>Click to edit Master title style</a:t>
             </a:r>
-            <a:endParaRPr lang="en-US"/>
           </a:p>
         </p:txBody>
       </p:sp>
@@ -1134,10 +1144,9 @@
           </a:lstStyle>
           <a:p>
             <a:r>
-              <a:rPr lang="en-US" smtClean="0"/>
+              <a:rPr lang="en-US"/>
               <a:t>Click to edit Master subtitle style</a:t>
             </a:r>
-            <a:endParaRPr lang="en-US"/>
           </a:p>
         </p:txBody>
       </p:sp>
@@ -1159,7 +1168,7 @@
             <a:fld id="{1D8BD707-D9CF-40AE-B4C6-C98DA3205C09}" type="datetimeFigureOut">
               <a:rPr lang="en-US" smtClean="0"/>
               <a:pPr/>
-              <a:t>8/1/2011</a:t>
+              <a:t>10/24/2026</a:t>
             </a:fld>
             <a:endParaRPr lang="en-US"/>
           </a:p>
@@ -1202,7 +1211,7 @@
             <a:fld id="{B6F15528-21DE-4FAA-801E-634DDDAF4B2B}" type="slidenum">
               <a:rPr lang="en-US" smtClean="0"/>
               <a:pPr/>
-              <a:t>‹#›</a:t>
+              <a:t>‹Nº›</a:t>
             </a:fld>
             <a:endParaRPr lang="en-US"/>
           </a:p>
@@ -1249,10 +1258,9 @@
           <a:lstStyle/>
           <a:p>
             <a:r>
-              <a:rPr lang="en-US" smtClean="0"/>
+              <a:rPr lang="en-US"/>
               <a:t>Click to edit Master title style</a:t>
             </a:r>
-            <a:endParaRPr lang="en-US"/>
           </a:p>
         </p:txBody>
       </p:sp>
@@ -1273,38 +1281,37 @@
           <a:p>
             <a:pPr lvl="0"/>
             <a:r>
-              <a:rPr lang="en-US" smtClean="0"/>
+              <a:rPr lang="en-US"/>
               <a:t>Click to edit Master text styles</a:t>
             </a:r>
           </a:p>
           <a:p>
             <a:pPr lvl="1"/>
             <a:r>
-              <a:rPr lang="en-US" smtClean="0"/>
+              <a:rPr lang="en-US"/>
               <a:t>Second level</a:t>
             </a:r>
           </a:p>
           <a:p>
             <a:pPr lvl="2"/>
             <a:r>
-              <a:rPr lang="en-US" smtClean="0"/>
+              <a:rPr lang="en-US"/>
               <a:t>Third level</a:t>
             </a:r>
           </a:p>
           <a:p>
             <a:pPr lvl="3"/>
             <a:r>
-              <a:rPr lang="en-US" smtClean="0"/>
+              <a:rPr lang="en-US"/>
               <a:t>Fourth level</a:t>
             </a:r>
           </a:p>
           <a:p>
             <a:pPr lvl="4"/>
             <a:r>
-              <a:rPr lang="en-US" smtClean="0"/>
+              <a:rPr lang="en-US"/>
               <a:t>Fifth level</a:t>
             </a:r>
-            <a:endParaRPr lang="en-US"/>
           </a:p>
         </p:txBody>
       </p:sp>
@@ -1326,7 +1333,7 @@
             <a:fld id="{1D8BD707-D9CF-40AE-B4C6-C98DA3205C09}" type="datetimeFigureOut">
               <a:rPr lang="en-US" smtClean="0"/>
               <a:pPr/>
-              <a:t>8/1/2011</a:t>
+              <a:t>10/24/2026</a:t>
             </a:fld>
             <a:endParaRPr lang="en-US"/>
           </a:p>
@@ -1369,7 +1376,7 @@
             <a:fld id="{B6F15528-21DE-4FAA-801E-634DDDAF4B2B}" type="slidenum">
               <a:rPr lang="en-US" smtClean="0"/>
               <a:pPr/>
-              <a:t>‹#›</a:t>
+              <a:t>‹Nº›</a:t>
             </a:fld>
             <a:endParaRPr lang="en-US"/>
           </a:p>
@@ -1421,10 +1428,9 @@
           <a:lstStyle/>
           <a:p>
             <a:r>
-              <a:rPr lang="en-US" smtClean="0"/>
+              <a:rPr lang="en-US"/>
               <a:t>Click to edit Master title style</a:t>
             </a:r>
-            <a:endParaRPr lang="en-US"/>
           </a:p>
         </p:txBody>
       </p:sp>
@@ -1450,38 +1456,37 @@
           <a:p>
             <a:pPr lvl="0"/>
             <a:r>
-              <a:rPr lang="en-US" smtClean="0"/>
+              <a:rPr lang="en-US"/>
               <a:t>Click to edit Master text styles</a:t>
             </a:r>
           </a:p>
           <a:p>
             <a:pPr lvl="1"/>
             <a:r>
-              <a:rPr lang="en-US" smtClean="0"/>
+              <a:rPr lang="en-US"/>
               <a:t>Second level</a:t>
             </a:r>
           </a:p>
           <a:p>
             <a:pPr lvl="2"/>
             <a:r>
-              <a:rPr lang="en-US" smtClean="0"/>
+              <a:rPr lang="en-US"/>
               <a:t>Third level</a:t>
             </a:r>
           </a:p>
           <a:p>
             <a:pPr lvl="3"/>
             <a:r>
-              <a:rPr lang="en-US" smtClean="0"/>
+              <a:rPr lang="en-US"/>
               <a:t>Fourth level</a:t>
             </a:r>
           </a:p>
           <a:p>
             <a:pPr lvl="4"/>
             <a:r>
-              <a:rPr lang="en-US" smtClean="0"/>
+              <a:rPr lang="en-US"/>
               <a:t>Fifth level</a:t>
             </a:r>
-            <a:endParaRPr lang="en-US"/>
           </a:p>
         </p:txBody>
       </p:sp>
@@ -1503,7 +1508,7 @@
             <a:fld id="{1D8BD707-D9CF-40AE-B4C6-C98DA3205C09}" type="datetimeFigureOut">
               <a:rPr lang="en-US" smtClean="0"/>
               <a:pPr/>
-              <a:t>8/1/2011</a:t>
+              <a:t>10/24/2026</a:t>
             </a:fld>
             <a:endParaRPr lang="en-US"/>
           </a:p>
@@ -1546,7 +1551,7 @@
             <a:fld id="{B6F15528-21DE-4FAA-801E-634DDDAF4B2B}" type="slidenum">
               <a:rPr lang="en-US" smtClean="0"/>
               <a:pPr/>
-              <a:t>‹#›</a:t>
+              <a:t>‹Nº›</a:t>
             </a:fld>
             <a:endParaRPr lang="en-US"/>
           </a:p>
@@ -1593,10 +1598,9 @@
           <a:lstStyle/>
           <a:p>
             <a:r>
-              <a:rPr lang="en-US" smtClean="0"/>
+              <a:rPr lang="en-US"/>
               <a:t>Click to edit Master title style</a:t>
             </a:r>
-            <a:endParaRPr lang="en-US"/>
           </a:p>
         </p:txBody>
       </p:sp>
@@ -1617,38 +1621,37 @@
           <a:p>
             <a:pPr lvl="0"/>
             <a:r>
-              <a:rPr lang="en-US" smtClean="0"/>
+              <a:rPr lang="en-US"/>
               <a:t>Click to edit Master text styles</a:t>
             </a:r>
           </a:p>
           <a:p>
             <a:pPr lvl="1"/>
             <a:r>
-              <a:rPr lang="en-US" smtClean="0"/>
+              <a:rPr lang="en-US"/>
               <a:t>Second level</a:t>
             </a:r>
           </a:p>
           <a:p>
             <a:pPr lvl="2"/>
             <a:r>
-              <a:rPr lang="en-US" smtClean="0"/>
+              <a:rPr lang="en-US"/>
               <a:t>Third level</a:t>
             </a:r>
           </a:p>
           <a:p>
             <a:pPr lvl="3"/>
             <a:r>
-              <a:rPr lang="en-US" smtClean="0"/>
+              <a:rPr lang="en-US"/>
               <a:t>Fourth level</a:t>
             </a:r>
           </a:p>
           <a:p>
             <a:pPr lvl="4"/>
             <a:r>
-              <a:rPr lang="en-US" smtClean="0"/>
+              <a:rPr lang="en-US"/>
               <a:t>Fifth level</a:t>
             </a:r>
-            <a:endParaRPr lang="en-US"/>
           </a:p>
         </p:txBody>
       </p:sp>
@@ -1670,7 +1673,7 @@
             <a:fld id="{1D8BD707-D9CF-40AE-B4C6-C98DA3205C09}" type="datetimeFigureOut">
               <a:rPr lang="en-US" smtClean="0"/>
               <a:pPr/>
-              <a:t>8/1/2011</a:t>
+              <a:t>10/24/2026</a:t>
             </a:fld>
             <a:endParaRPr lang="en-US"/>
           </a:p>
@@ -1713,7 +1716,7 @@
             <a:fld id="{B6F15528-21DE-4FAA-801E-634DDDAF4B2B}" type="slidenum">
               <a:rPr lang="en-US" smtClean="0"/>
               <a:pPr/>
-              <a:t>‹#›</a:t>
+              <a:t>‹Nº›</a:t>
             </a:fld>
             <a:endParaRPr lang="en-US"/>
           </a:p>
@@ -1769,10 +1772,9 @@
           </a:lstStyle>
           <a:p>
             <a:r>
-              <a:rPr lang="en-US" smtClean="0"/>
+              <a:rPr lang="en-US"/>
               <a:t>Click to edit Master title style</a:t>
             </a:r>
-            <a:endParaRPr lang="en-US"/>
           </a:p>
         </p:txBody>
       </p:sp>
@@ -1889,7 +1891,7 @@
           <a:p>
             <a:pPr lvl="0"/>
             <a:r>
-              <a:rPr lang="en-US" smtClean="0"/>
+              <a:rPr lang="en-US"/>
               <a:t>Click to edit Master text styles</a:t>
             </a:r>
           </a:p>
@@ -1913,7 +1915,7 @@
             <a:fld id="{1D8BD707-D9CF-40AE-B4C6-C98DA3205C09}" type="datetimeFigureOut">
               <a:rPr lang="en-US" smtClean="0"/>
               <a:pPr/>
-              <a:t>8/1/2011</a:t>
+              <a:t>10/24/2026</a:t>
             </a:fld>
             <a:endParaRPr lang="en-US"/>
           </a:p>
@@ -1956,7 +1958,7 @@
             <a:fld id="{B6F15528-21DE-4FAA-801E-634DDDAF4B2B}" type="slidenum">
               <a:rPr lang="en-US" smtClean="0"/>
               <a:pPr/>
-              <a:t>‹#›</a:t>
+              <a:t>‹Nº›</a:t>
             </a:fld>
             <a:endParaRPr lang="en-US"/>
           </a:p>
@@ -2003,10 +2005,9 @@
           <a:lstStyle/>
           <a:p>
             <a:r>
-              <a:rPr lang="en-US" smtClean="0"/>
+              <a:rPr lang="en-US"/>
               <a:t>Click to edit Master title style</a:t>
             </a:r>
-            <a:endParaRPr lang="en-US"/>
           </a:p>
         </p:txBody>
       </p:sp>
@@ -2060,38 +2061,37 @@
           <a:p>
             <a:pPr lvl="0"/>
             <a:r>
-              <a:rPr lang="en-US" smtClean="0"/>
+              <a:rPr lang="en-US"/>
               <a:t>Click to edit Master text styles</a:t>
             </a:r>
           </a:p>
           <a:p>
             <a:pPr lvl="1"/>
             <a:r>
-              <a:rPr lang="en-US" smtClean="0"/>
+              <a:rPr lang="en-US"/>
               <a:t>Second level</a:t>
             </a:r>
           </a:p>
           <a:p>
             <a:pPr lvl="2"/>
             <a:r>
-              <a:rPr lang="en-US" smtClean="0"/>
+              <a:rPr lang="en-US"/>
               <a:t>Third level</a:t>
             </a:r>
           </a:p>
           <a:p>
             <a:pPr lvl="3"/>
             <a:r>
-              <a:rPr lang="en-US" smtClean="0"/>
+              <a:rPr lang="en-US"/>
               <a:t>Fourth level</a:t>
             </a:r>
           </a:p>
           <a:p>
             <a:pPr lvl="4"/>
             <a:r>
-              <a:rPr lang="en-US" smtClean="0"/>
+              <a:rPr lang="en-US"/>
               <a:t>Fifth level</a:t>
             </a:r>
-            <a:endParaRPr lang="en-US"/>
           </a:p>
         </p:txBody>
       </p:sp>
@@ -2145,38 +2145,37 @@
           <a:p>
             <a:pPr lvl="0"/>
             <a:r>
-              <a:rPr lang="en-US" smtClean="0"/>
+              <a:rPr lang="en-US"/>
               <a:t>Click to edit Master text styles</a:t>
             </a:r>
           </a:p>
           <a:p>
             <a:pPr lvl="1"/>
             <a:r>
-              <a:rPr lang="en-US" smtClean="0"/>
+              <a:rPr lang="en-US"/>
               <a:t>Second level</a:t>
             </a:r>
           </a:p>
           <a:p>
             <a:pPr lvl="2"/>
             <a:r>
-              <a:rPr lang="en-US" smtClean="0"/>
+              <a:rPr lang="en-US"/>
               <a:t>Third level</a:t>
             </a:r>
           </a:p>
           <a:p>
             <a:pPr lvl="3"/>
             <a:r>
-              <a:rPr lang="en-US" smtClean="0"/>
+              <a:rPr lang="en-US"/>
               <a:t>Fourth level</a:t>
             </a:r>
           </a:p>
           <a:p>
             <a:pPr lvl="4"/>
             <a:r>
-              <a:rPr lang="en-US" smtClean="0"/>
+              <a:rPr lang="en-US"/>
               <a:t>Fifth level</a:t>
             </a:r>
-            <a:endParaRPr lang="en-US"/>
           </a:p>
         </p:txBody>
       </p:sp>
@@ -2198,7 +2197,7 @@
             <a:fld id="{1D8BD707-D9CF-40AE-B4C6-C98DA3205C09}" type="datetimeFigureOut">
               <a:rPr lang="en-US" smtClean="0"/>
               <a:pPr/>
-              <a:t>8/1/2011</a:t>
+              <a:t>10/24/2026</a:t>
             </a:fld>
             <a:endParaRPr lang="en-US"/>
           </a:p>
@@ -2241,7 +2240,7 @@
             <a:fld id="{B6F15528-21DE-4FAA-801E-634DDDAF4B2B}" type="slidenum">
               <a:rPr lang="en-US" smtClean="0"/>
               <a:pPr/>
-              <a:t>‹#›</a:t>
+              <a:t>‹Nº›</a:t>
             </a:fld>
             <a:endParaRPr lang="en-US"/>
           </a:p>
@@ -2292,10 +2291,9 @@
           </a:lstStyle>
           <a:p>
             <a:r>
-              <a:rPr lang="en-US" smtClean="0"/>
+              <a:rPr lang="en-US"/>
               <a:t>Click to edit Master title style</a:t>
             </a:r>
-            <a:endParaRPr lang="en-US"/>
           </a:p>
         </p:txBody>
       </p:sp>
@@ -2358,7 +2356,7 @@
           <a:p>
             <a:pPr lvl="0"/>
             <a:r>
-              <a:rPr lang="en-US" smtClean="0"/>
+              <a:rPr lang="en-US"/>
               <a:t>Click to edit Master text styles</a:t>
             </a:r>
           </a:p>
@@ -2414,38 +2412,37 @@
           <a:p>
             <a:pPr lvl="0"/>
             <a:r>
-              <a:rPr lang="en-US" smtClean="0"/>
+              <a:rPr lang="en-US"/>
               <a:t>Click to edit Master text styles</a:t>
             </a:r>
           </a:p>
           <a:p>
             <a:pPr lvl="1"/>
             <a:r>
-              <a:rPr lang="en-US" smtClean="0"/>
+              <a:rPr lang="en-US"/>
               <a:t>Second level</a:t>
             </a:r>
           </a:p>
           <a:p>
             <a:pPr lvl="2"/>
             <a:r>
-              <a:rPr lang="en-US" smtClean="0"/>
+              <a:rPr lang="en-US"/>
               <a:t>Third level</a:t>
             </a:r>
           </a:p>
           <a:p>
             <a:pPr lvl="3"/>
             <a:r>
-              <a:rPr lang="en-US" smtClean="0"/>
+              <a:rPr lang="en-US"/>
               <a:t>Fourth level</a:t>
             </a:r>
           </a:p>
           <a:p>
             <a:pPr lvl="4"/>
             <a:r>
-              <a:rPr lang="en-US" smtClean="0"/>
+              <a:rPr lang="en-US"/>
               <a:t>Fifth level</a:t>
             </a:r>
-            <a:endParaRPr lang="en-US"/>
           </a:p>
         </p:txBody>
       </p:sp>
@@ -2508,7 +2505,7 @@
           <a:p>
             <a:pPr lvl="0"/>
             <a:r>
-              <a:rPr lang="en-US" smtClean="0"/>
+              <a:rPr lang="en-US"/>
               <a:t>Click to edit Master text styles</a:t>
             </a:r>
           </a:p>
@@ -2564,38 +2561,37 @@
           <a:p>
             <a:pPr lvl="0"/>
             <a:r>
-              <a:rPr lang="en-US" smtClean="0"/>
+              <a:rPr lang="en-US"/>
               <a:t>Click to edit Master text styles</a:t>
             </a:r>
           </a:p>
           <a:p>
             <a:pPr lvl="1"/>
             <a:r>
-              <a:rPr lang="en-US" smtClean="0"/>
+              <a:rPr lang="en-US"/>
               <a:t>Second level</a:t>
             </a:r>
           </a:p>
           <a:p>
             <a:pPr lvl="2"/>
             <a:r>
-              <a:rPr lang="en-US" smtClean="0"/>
+              <a:rPr lang="en-US"/>
               <a:t>Third level</a:t>
             </a:r>
           </a:p>
           <a:p>
             <a:pPr lvl="3"/>
             <a:r>
-              <a:rPr lang="en-US" smtClean="0"/>
+              <a:rPr lang="en-US"/>
               <a:t>Fourth level</a:t>
             </a:r>
           </a:p>
           <a:p>
             <a:pPr lvl="4"/>
             <a:r>
-              <a:rPr lang="en-US" smtClean="0"/>
+              <a:rPr lang="en-US"/>
               <a:t>Fifth level</a:t>
             </a:r>
-            <a:endParaRPr lang="en-US"/>
           </a:p>
         </p:txBody>
       </p:sp>
@@ -2617,7 +2613,7 @@
             <a:fld id="{1D8BD707-D9CF-40AE-B4C6-C98DA3205C09}" type="datetimeFigureOut">
               <a:rPr lang="en-US" smtClean="0"/>
               <a:pPr/>
-              <a:t>8/1/2011</a:t>
+              <a:t>10/24/2026</a:t>
             </a:fld>
             <a:endParaRPr lang="en-US"/>
           </a:p>
@@ -2660,7 +2656,7 @@
             <a:fld id="{B6F15528-21DE-4FAA-801E-634DDDAF4B2B}" type="slidenum">
               <a:rPr lang="en-US" smtClean="0"/>
               <a:pPr/>
-              <a:t>‹#›</a:t>
+              <a:t>‹Nº›</a:t>
             </a:fld>
             <a:endParaRPr lang="en-US"/>
           </a:p>
@@ -2707,10 +2703,9 @@
           <a:lstStyle/>
           <a:p>
             <a:r>
-              <a:rPr lang="en-US" smtClean="0"/>
+              <a:rPr lang="en-US"/>
               <a:t>Click to edit Master title style</a:t>
             </a:r>
-            <a:endParaRPr lang="en-US"/>
           </a:p>
         </p:txBody>
       </p:sp>
@@ -2732,7 +2727,7 @@
             <a:fld id="{1D8BD707-D9CF-40AE-B4C6-C98DA3205C09}" type="datetimeFigureOut">
               <a:rPr lang="en-US" smtClean="0"/>
               <a:pPr/>
-              <a:t>8/1/2011</a:t>
+              <a:t>10/24/2026</a:t>
             </a:fld>
             <a:endParaRPr lang="en-US"/>
           </a:p>
@@ -2775,7 +2770,7 @@
             <a:fld id="{B6F15528-21DE-4FAA-801E-634DDDAF4B2B}" type="slidenum">
               <a:rPr lang="en-US" smtClean="0"/>
               <a:pPr/>
-              <a:t>‹#›</a:t>
+              <a:t>‹Nº›</a:t>
             </a:fld>
             <a:endParaRPr lang="en-US"/>
           </a:p>
@@ -2824,7 +2819,7 @@
             <a:fld id="{1D8BD707-D9CF-40AE-B4C6-C98DA3205C09}" type="datetimeFigureOut">
               <a:rPr lang="en-US" smtClean="0"/>
               <a:pPr/>
-              <a:t>8/1/2011</a:t>
+              <a:t>10/24/2026</a:t>
             </a:fld>
             <a:endParaRPr lang="en-US"/>
           </a:p>
@@ -2867,7 +2862,7 @@
             <a:fld id="{B6F15528-21DE-4FAA-801E-634DDDAF4B2B}" type="slidenum">
               <a:rPr lang="en-US" smtClean="0"/>
               <a:pPr/>
-              <a:t>‹#›</a:t>
+              <a:t>‹Nº›</a:t>
             </a:fld>
             <a:endParaRPr lang="en-US"/>
           </a:p>
@@ -2923,10 +2918,9 @@
           </a:lstStyle>
           <a:p>
             <a:r>
-              <a:rPr lang="en-US" smtClean="0"/>
+              <a:rPr lang="en-US"/>
               <a:t>Click to edit Master title style</a:t>
             </a:r>
-            <a:endParaRPr lang="en-US"/>
           </a:p>
         </p:txBody>
       </p:sp>
@@ -2980,38 +2974,37 @@
           <a:p>
             <a:pPr lvl="0"/>
             <a:r>
-              <a:rPr lang="en-US" smtClean="0"/>
+              <a:rPr lang="en-US"/>
               <a:t>Click to edit Master text styles</a:t>
             </a:r>
           </a:p>
           <a:p>
             <a:pPr lvl="1"/>
             <a:r>
-              <a:rPr lang="en-US" smtClean="0"/>
+              <a:rPr lang="en-US"/>
               <a:t>Second level</a:t>
             </a:r>
           </a:p>
           <a:p>
             <a:pPr lvl="2"/>
             <a:r>
-              <a:rPr lang="en-US" smtClean="0"/>
+              <a:rPr lang="en-US"/>
               <a:t>Third level</a:t>
             </a:r>
           </a:p>
           <a:p>
             <a:pPr lvl="3"/>
             <a:r>
-              <a:rPr lang="en-US" smtClean="0"/>
+              <a:rPr lang="en-US"/>
               <a:t>Fourth level</a:t>
             </a:r>
           </a:p>
           <a:p>
             <a:pPr lvl="4"/>
             <a:r>
-              <a:rPr lang="en-US" smtClean="0"/>
+              <a:rPr lang="en-US"/>
               <a:t>Fifth level</a:t>
             </a:r>
-            <a:endParaRPr lang="en-US"/>
           </a:p>
         </p:txBody>
       </p:sp>
@@ -3074,7 +3067,7 @@
           <a:p>
             <a:pPr lvl="0"/>
             <a:r>
-              <a:rPr lang="en-US" smtClean="0"/>
+              <a:rPr lang="en-US"/>
               <a:t>Click to edit Master text styles</a:t>
             </a:r>
           </a:p>
@@ -3098,7 +3091,7 @@
             <a:fld id="{1D8BD707-D9CF-40AE-B4C6-C98DA3205C09}" type="datetimeFigureOut">
               <a:rPr lang="en-US" smtClean="0"/>
               <a:pPr/>
-              <a:t>8/1/2011</a:t>
+              <a:t>10/24/2026</a:t>
             </a:fld>
             <a:endParaRPr lang="en-US"/>
           </a:p>
@@ -3141,7 +3134,7 @@
             <a:fld id="{B6F15528-21DE-4FAA-801E-634DDDAF4B2B}" type="slidenum">
               <a:rPr lang="en-US" smtClean="0"/>
               <a:pPr/>
-              <a:t>‹#›</a:t>
+              <a:t>‹Nº›</a:t>
             </a:fld>
             <a:endParaRPr lang="en-US"/>
           </a:p>
@@ -3197,10 +3190,9 @@
           </a:lstStyle>
           <a:p>
             <a:r>
-              <a:rPr lang="en-US" smtClean="0"/>
+              <a:rPr lang="en-US"/>
               <a:t>Click to edit Master title style</a:t>
             </a:r>
-            <a:endParaRPr lang="en-US"/>
           </a:p>
         </p:txBody>
       </p:sp>
@@ -3324,7 +3316,7 @@
           <a:p>
             <a:pPr lvl="0"/>
             <a:r>
-              <a:rPr lang="en-US" smtClean="0"/>
+              <a:rPr lang="en-US"/>
               <a:t>Click to edit Master text styles</a:t>
             </a:r>
           </a:p>
@@ -3348,7 +3340,7 @@
             <a:fld id="{1D8BD707-D9CF-40AE-B4C6-C98DA3205C09}" type="datetimeFigureOut">
               <a:rPr lang="en-US" smtClean="0"/>
               <a:pPr/>
-              <a:t>8/1/2011</a:t>
+              <a:t>10/24/2026</a:t>
             </a:fld>
             <a:endParaRPr lang="en-US"/>
           </a:p>
@@ -3391,7 +3383,7 @@
             <a:fld id="{B6F15528-21DE-4FAA-801E-634DDDAF4B2B}" type="slidenum">
               <a:rPr lang="en-US" smtClean="0"/>
               <a:pPr/>
-              <a:t>‹#›</a:t>
+              <a:t>‹Nº›</a:t>
             </a:fld>
             <a:endParaRPr lang="en-US"/>
           </a:p>
@@ -3453,10 +3445,9 @@
           <a:lstStyle/>
           <a:p>
             <a:r>
-              <a:rPr lang="en-US" smtClean="0"/>
+              <a:rPr lang="en-US"/>
               <a:t>Click to edit Master title style</a:t>
             </a:r>
-            <a:endParaRPr lang="en-US"/>
           </a:p>
         </p:txBody>
       </p:sp>
@@ -3487,38 +3478,37 @@
           <a:p>
             <a:pPr lvl="0"/>
             <a:r>
-              <a:rPr lang="en-US" smtClean="0"/>
+              <a:rPr lang="en-US"/>
               <a:t>Click to edit Master text styles</a:t>
             </a:r>
           </a:p>
           <a:p>
             <a:pPr lvl="1"/>
             <a:r>
-              <a:rPr lang="en-US" smtClean="0"/>
+              <a:rPr lang="en-US"/>
               <a:t>Second level</a:t>
             </a:r>
           </a:p>
           <a:p>
             <a:pPr lvl="2"/>
             <a:r>
-              <a:rPr lang="en-US" smtClean="0"/>
+              <a:rPr lang="en-US"/>
               <a:t>Third level</a:t>
             </a:r>
           </a:p>
           <a:p>
             <a:pPr lvl="3"/>
             <a:r>
-              <a:rPr lang="en-US" smtClean="0"/>
+              <a:rPr lang="en-US"/>
               <a:t>Fourth level</a:t>
             </a:r>
           </a:p>
           <a:p>
             <a:pPr lvl="4"/>
             <a:r>
-              <a:rPr lang="en-US" smtClean="0"/>
+              <a:rPr lang="en-US"/>
               <a:t>Fifth level</a:t>
             </a:r>
-            <a:endParaRPr lang="en-US"/>
           </a:p>
         </p:txBody>
       </p:sp>
@@ -3558,7 +3548,7 @@
             <a:fld id="{1D8BD707-D9CF-40AE-B4C6-C98DA3205C09}" type="datetimeFigureOut">
               <a:rPr lang="en-US" smtClean="0"/>
               <a:pPr/>
-              <a:t>8/1/2011</a:t>
+              <a:t>10/24/2026</a:t>
             </a:fld>
             <a:endParaRPr lang="en-US"/>
           </a:p>
@@ -3637,7 +3627,7 @@
             <a:fld id="{B6F15528-21DE-4FAA-801E-634DDDAF4B2B}" type="slidenum">
               <a:rPr lang="en-US" smtClean="0"/>
               <a:pPr/>
-              <a:t>‹#›</a:t>
+              <a:t>‹Nº›</a:t>
             </a:fld>
             <a:endParaRPr lang="en-US"/>
           </a:p>
@@ -3913,13 +3903,14 @@
 </file>
 
 <file path=ppt/slides/slide1.xml><?xml version="1.0" encoding="utf-8"?>
-<p:sld xmlns:p="http://schemas.openxmlformats.org/presentationml/2006/main" xmlns:a="http://schemas.openxmlformats.org/drawingml/2006/main" xmlns:r="http://schemas.openxmlformats.org/officeDocument/2006/relationships">
+<p:sld xmlns:a="http://schemas.openxmlformats.org/drawingml/2006/main" xmlns:r="http://schemas.openxmlformats.org/officeDocument/2006/relationships" xmlns:p="http://schemas.openxmlformats.org/presentationml/2006/main">
   <p:cSld>
     <p:bg>
       <p:bgPr>
         <a:solidFill>
           <a:srgbClr val="DAE5FC"/>
         </a:solidFill>
+        <a:effectLst/>
       </p:bgPr>
     </p:bg>
     <p:spTree>
@@ -3938,12 +3929,12 @@
       </p:grpSpPr>
       <p:sp>
         <p:nvSpPr>
-          <p:cNvPr name="Freeform 2" id="2"/>
+          <p:cNvPr id="2" name="Freeform 2"/>
           <p:cNvSpPr/>
           <p:nvPr/>
         </p:nvSpPr>
         <p:spPr>
-          <a:xfrm flipH="false" flipV="false" rot="0">
+          <a:xfrm>
             <a:off x="0" y="0"/>
             <a:ext cx="18288000" cy="10287000"/>
           </a:xfrm>
@@ -3952,9 +3943,9 @@
             <a:gdLst/>
             <a:ahLst/>
             <a:cxnLst/>
-            <a:rect r="r" b="b" t="t" l="l"/>
+            <a:rect l="l" t="t" r="r" b="b"/>
             <a:pathLst>
-              <a:path h="10287000" w="18288000">
+              <a:path w="18288000" h="10287000">
                 <a:moveTo>
                   <a:pt x="0" y="0"/>
                 </a:moveTo>
@@ -3977,23 +3968,26 @@
           <a:blipFill>
             <a:blip r:embed="rId2"/>
             <a:stretch>
-              <a:fillRect l="0" t="0" r="0" b="0"/>
+              <a:fillRect/>
             </a:stretch>
           </a:blipFill>
         </p:spPr>
         <p:txBody>
           <a:bodyPr/>
-          <a:p/>
+          <a:lstStyle/>
+          <a:p>
+            <a:endParaRPr/>
+          </a:p>
         </p:txBody>
       </p:sp>
       <p:grpSp>
         <p:nvGrpSpPr>
-          <p:cNvPr name="Group 3" id="3"/>
+          <p:cNvPr id="3" name="Group 3"/>
           <p:cNvGrpSpPr/>
           <p:nvPr/>
         </p:nvGrpSpPr>
         <p:grpSpPr>
-          <a:xfrm rot="0">
+          <a:xfrm>
             <a:off x="13210958" y="1291507"/>
             <a:ext cx="4426119" cy="7297503"/>
             <a:chOff x="0" y="0"/>
@@ -4002,12 +3996,12 @@
         </p:grpSpPr>
         <p:grpSp>
           <p:nvGrpSpPr>
-            <p:cNvPr name="Group 4" id="4"/>
+            <p:cNvPr id="4" name="Group 4"/>
             <p:cNvGrpSpPr/>
             <p:nvPr/>
           </p:nvGrpSpPr>
           <p:grpSpPr>
-            <a:xfrm rot="0">
+            <a:xfrm>
               <a:off x="3659312" y="0"/>
               <a:ext cx="2242180" cy="2242180"/>
               <a:chOff x="0" y="0"/>
@@ -4016,12 +4010,12 @@
           </p:grpSpPr>
           <p:sp>
             <p:nvSpPr>
-              <p:cNvPr name="Freeform 5" id="5"/>
+              <p:cNvPr id="5" name="Freeform 5"/>
               <p:cNvSpPr/>
               <p:nvPr/>
             </p:nvSpPr>
             <p:spPr>
-              <a:xfrm flipH="false" flipV="false" rot="0">
+              <a:xfrm>
                 <a:off x="0" y="0"/>
                 <a:ext cx="812800" cy="812800"/>
               </a:xfrm>
@@ -4030,9 +4024,9 @@
                 <a:gdLst/>
                 <a:ahLst/>
                 <a:cxnLst/>
-                <a:rect r="r" b="b" t="t" l="l"/>
+                <a:rect l="l" t="t" r="r" b="b"/>
                 <a:pathLst>
-                  <a:path h="812800" w="812800">
+                  <a:path w="812800" h="812800">
                     <a:moveTo>
                       <a:pt x="406400" y="0"/>
                     </a:moveTo>
@@ -4063,24 +4057,27 @@
               <a:blipFill>
                 <a:blip r:embed="rId3"/>
                 <a:stretch>
-                  <a:fillRect l="-78303" t="0" r="-78303" b="0"/>
+                  <a:fillRect/>
                 </a:stretch>
               </a:blipFill>
             </p:spPr>
             <p:txBody>
               <a:bodyPr/>
-              <a:p/>
+              <a:lstStyle/>
+              <a:p>
+                <a:endParaRPr dirty="0"/>
+              </a:p>
             </p:txBody>
           </p:sp>
         </p:grpSp>
         <p:sp>
           <p:nvSpPr>
-            <p:cNvPr name="TextBox 6" id="6"/>
-            <p:cNvSpPr txBox="true"/>
+            <p:cNvPr id="6" name="TextBox 6"/>
+            <p:cNvSpPr txBox="1"/>
             <p:nvPr/>
           </p:nvSpPr>
           <p:spPr>
-            <a:xfrm rot="0">
+            <a:xfrm>
               <a:off x="-1450604" y="417572"/>
               <a:ext cx="4618880" cy="438841"/>
             </a:xfrm>
@@ -4089,7 +4086,7 @@
             </a:prstGeom>
           </p:spPr>
           <p:txBody>
-            <a:bodyPr anchor="t" rtlCol="false" tIns="0" lIns="0" bIns="0" rIns="0">
+            <a:bodyPr lIns="0" tIns="0" rIns="0" bIns="0" rtlCol="0" anchor="t">
               <a:spAutoFit/>
             </a:bodyPr>
             <a:lstStyle/>
@@ -4116,12 +4113,12 @@
         </p:sp>
         <p:sp>
           <p:nvSpPr>
-            <p:cNvPr name="TextBox 7" id="7"/>
-            <p:cNvSpPr txBox="true"/>
+            <p:cNvPr id="7" name="TextBox 7"/>
+            <p:cNvSpPr txBox="1"/>
             <p:nvPr/>
           </p:nvSpPr>
           <p:spPr>
-            <a:xfrm rot="0">
+            <a:xfrm>
               <a:off x="31076" y="869487"/>
               <a:ext cx="4581599" cy="455581"/>
             </a:xfrm>
@@ -4130,7 +4127,7 @@
             </a:prstGeom>
           </p:spPr>
           <p:txBody>
-            <a:bodyPr anchor="t" rtlCol="false" tIns="0" lIns="0" bIns="0" rIns="0">
+            <a:bodyPr lIns="0" tIns="0" rIns="0" bIns="0" rtlCol="0" anchor="t">
               <a:spAutoFit/>
             </a:bodyPr>
             <a:lstStyle/>
@@ -4140,29 +4137,18 @@
                   <a:spcPts val="2835"/>
                 </a:lnSpc>
               </a:pPr>
-              <a:r>
-                <a:rPr lang="en-US" sz="2025">
-                  <a:solidFill>
-                    <a:srgbClr val="000000"/>
-                  </a:solidFill>
-                  <a:latin typeface="Fira Sans Light"/>
-                  <a:ea typeface="Fira Sans Light"/>
-                  <a:cs typeface="Fira Sans Light"/>
-                  <a:sym typeface="Fira Sans Light"/>
-                </a:rPr>
-                <a:t/>
-              </a:r>
+              <a:endParaRPr/>
             </a:p>
           </p:txBody>
         </p:sp>
         <p:grpSp>
           <p:nvGrpSpPr>
-            <p:cNvPr name="Group 8" id="8"/>
+            <p:cNvPr id="8" name="Group 8"/>
             <p:cNvGrpSpPr/>
             <p:nvPr/>
           </p:nvGrpSpPr>
           <p:grpSpPr>
-            <a:xfrm rot="0">
+            <a:xfrm>
               <a:off x="3628237" y="2495463"/>
               <a:ext cx="2242180" cy="2242180"/>
               <a:chOff x="0" y="0"/>
@@ -4171,12 +4157,12 @@
           </p:grpSpPr>
           <p:sp>
             <p:nvSpPr>
-              <p:cNvPr name="Freeform 9" id="9"/>
+              <p:cNvPr id="9" name="Freeform 9"/>
               <p:cNvSpPr/>
               <p:nvPr/>
             </p:nvSpPr>
             <p:spPr>
-              <a:xfrm flipH="false" flipV="false" rot="0">
+              <a:xfrm>
                 <a:off x="0" y="0"/>
                 <a:ext cx="812800" cy="812800"/>
               </a:xfrm>
@@ -4185,9 +4171,9 @@
                 <a:gdLst/>
                 <a:ahLst/>
                 <a:cxnLst/>
-                <a:rect r="r" b="b" t="t" l="l"/>
+                <a:rect l="l" t="t" r="r" b="b"/>
                 <a:pathLst>
-                  <a:path h="812800" w="812800">
+                  <a:path w="812800" h="812800">
                     <a:moveTo>
                       <a:pt x="406400" y="0"/>
                     </a:moveTo>
@@ -4216,26 +4202,29 @@
                 </a:pathLst>
               </a:custGeom>
               <a:blipFill>
-                <a:blip r:embed="rId3"/>
+                <a:blip r:embed="rId4"/>
                 <a:stretch>
-                  <a:fillRect l="-78303" t="0" r="-78303" b="0"/>
+                  <a:fillRect/>
                 </a:stretch>
               </a:blipFill>
             </p:spPr>
             <p:txBody>
               <a:bodyPr/>
-              <a:p/>
+              <a:lstStyle/>
+              <a:p>
+                <a:endParaRPr/>
+              </a:p>
             </p:txBody>
           </p:sp>
         </p:grpSp>
         <p:sp>
           <p:nvSpPr>
-            <p:cNvPr name="TextBox 10" id="10"/>
-            <p:cNvSpPr txBox="true"/>
+            <p:cNvPr id="10" name="TextBox 10"/>
+            <p:cNvSpPr txBox="1"/>
             <p:nvPr/>
           </p:nvSpPr>
           <p:spPr>
-            <a:xfrm rot="0">
+            <a:xfrm>
               <a:off x="-1481680" y="2913035"/>
               <a:ext cx="4618880" cy="438841"/>
             </a:xfrm>
@@ -4244,7 +4233,7 @@
             </a:prstGeom>
           </p:spPr>
           <p:txBody>
-            <a:bodyPr anchor="t" rtlCol="false" tIns="0" lIns="0" bIns="0" rIns="0">
+            <a:bodyPr lIns="0" tIns="0" rIns="0" bIns="0" rtlCol="0" anchor="t">
               <a:spAutoFit/>
             </a:bodyPr>
             <a:lstStyle/>
@@ -4271,12 +4260,12 @@
         </p:sp>
         <p:sp>
           <p:nvSpPr>
-            <p:cNvPr name="TextBox 11" id="11"/>
-            <p:cNvSpPr txBox="true"/>
+            <p:cNvPr id="11" name="TextBox 11"/>
+            <p:cNvSpPr txBox="1"/>
             <p:nvPr/>
           </p:nvSpPr>
           <p:spPr>
-            <a:xfrm rot="0">
+            <a:xfrm>
               <a:off x="0" y="3364950"/>
               <a:ext cx="4581599" cy="455581"/>
             </a:xfrm>
@@ -4285,7 +4274,7 @@
             </a:prstGeom>
           </p:spPr>
           <p:txBody>
-            <a:bodyPr anchor="t" rtlCol="false" tIns="0" lIns="0" bIns="0" rIns="0">
+            <a:bodyPr lIns="0" tIns="0" rIns="0" bIns="0" rtlCol="0" anchor="t">
               <a:spAutoFit/>
             </a:bodyPr>
             <a:lstStyle/>
@@ -4295,29 +4284,18 @@
                   <a:spcPts val="2835"/>
                 </a:lnSpc>
               </a:pPr>
-              <a:r>
-                <a:rPr lang="en-US" sz="2025">
-                  <a:solidFill>
-                    <a:srgbClr val="000000"/>
-                  </a:solidFill>
-                  <a:latin typeface="Fira Sans Light"/>
-                  <a:ea typeface="Fira Sans Light"/>
-                  <a:cs typeface="Fira Sans Light"/>
-                  <a:sym typeface="Fira Sans Light"/>
-                </a:rPr>
-                <a:t/>
-              </a:r>
+              <a:endParaRPr/>
             </a:p>
           </p:txBody>
         </p:sp>
         <p:grpSp>
           <p:nvGrpSpPr>
-            <p:cNvPr name="Group 12" id="12"/>
+            <p:cNvPr id="12" name="Group 12"/>
             <p:cNvGrpSpPr/>
             <p:nvPr/>
           </p:nvGrpSpPr>
           <p:grpSpPr>
-            <a:xfrm rot="0">
+            <a:xfrm>
               <a:off x="3659312" y="4991643"/>
               <a:ext cx="2242180" cy="2242180"/>
               <a:chOff x="0" y="0"/>
@@ -4326,12 +4304,12 @@
           </p:grpSpPr>
           <p:sp>
             <p:nvSpPr>
-              <p:cNvPr name="Freeform 13" id="13"/>
+              <p:cNvPr id="13" name="Freeform 13"/>
               <p:cNvSpPr/>
               <p:nvPr/>
             </p:nvSpPr>
             <p:spPr>
-              <a:xfrm flipH="false" flipV="false" rot="0">
+              <a:xfrm>
                 <a:off x="0" y="0"/>
                 <a:ext cx="812800" cy="812800"/>
               </a:xfrm>
@@ -4340,9 +4318,9 @@
                 <a:gdLst/>
                 <a:ahLst/>
                 <a:cxnLst/>
-                <a:rect r="r" b="b" t="t" l="l"/>
+                <a:rect l="l" t="t" r="r" b="b"/>
                 <a:pathLst>
-                  <a:path h="812800" w="812800">
+                  <a:path w="812800" h="812800">
                     <a:moveTo>
                       <a:pt x="406400" y="0"/>
                     </a:moveTo>
@@ -4371,26 +4349,29 @@
                 </a:pathLst>
               </a:custGeom>
               <a:blipFill>
-                <a:blip r:embed="rId3"/>
+                <a:blip r:embed="rId5"/>
                 <a:stretch>
-                  <a:fillRect l="-78303" t="0" r="-78303" b="0"/>
+                  <a:fillRect/>
                 </a:stretch>
               </a:blipFill>
             </p:spPr>
             <p:txBody>
               <a:bodyPr/>
-              <a:p/>
+              <a:lstStyle/>
+              <a:p>
+                <a:endParaRPr/>
+              </a:p>
             </p:txBody>
           </p:sp>
         </p:grpSp>
         <p:sp>
           <p:nvSpPr>
-            <p:cNvPr name="TextBox 14" id="14"/>
-            <p:cNvSpPr txBox="true"/>
+            <p:cNvPr id="14" name="TextBox 14"/>
+            <p:cNvSpPr txBox="1"/>
             <p:nvPr/>
           </p:nvSpPr>
           <p:spPr>
-            <a:xfrm rot="0">
+            <a:xfrm>
               <a:off x="-1450604" y="5409215"/>
               <a:ext cx="4618880" cy="438841"/>
             </a:xfrm>
@@ -4399,7 +4380,7 @@
             </a:prstGeom>
           </p:spPr>
           <p:txBody>
-            <a:bodyPr anchor="t" rtlCol="false" tIns="0" lIns="0" bIns="0" rIns="0">
+            <a:bodyPr lIns="0" tIns="0" rIns="0" bIns="0" rtlCol="0" anchor="t">
               <a:spAutoFit/>
             </a:bodyPr>
             <a:lstStyle/>
@@ -4426,12 +4407,12 @@
         </p:sp>
         <p:sp>
           <p:nvSpPr>
-            <p:cNvPr name="TextBox 15" id="15"/>
-            <p:cNvSpPr txBox="true"/>
+            <p:cNvPr id="15" name="TextBox 15"/>
+            <p:cNvSpPr txBox="1"/>
             <p:nvPr/>
           </p:nvSpPr>
           <p:spPr>
-            <a:xfrm rot="0">
+            <a:xfrm>
               <a:off x="31076" y="5861130"/>
               <a:ext cx="4581599" cy="455581"/>
             </a:xfrm>
@@ -4440,7 +4421,7 @@
             </a:prstGeom>
           </p:spPr>
           <p:txBody>
-            <a:bodyPr anchor="t" rtlCol="false" tIns="0" lIns="0" bIns="0" rIns="0">
+            <a:bodyPr lIns="0" tIns="0" rIns="0" bIns="0" rtlCol="0" anchor="t">
               <a:spAutoFit/>
             </a:bodyPr>
             <a:lstStyle/>
@@ -4450,29 +4431,18 @@
                   <a:spcPts val="2835"/>
                 </a:lnSpc>
               </a:pPr>
-              <a:r>
-                <a:rPr lang="en-US" sz="2025">
-                  <a:solidFill>
-                    <a:srgbClr val="000000"/>
-                  </a:solidFill>
-                  <a:latin typeface="Fira Sans Light"/>
-                  <a:ea typeface="Fira Sans Light"/>
-                  <a:cs typeface="Fira Sans Light"/>
-                  <a:sym typeface="Fira Sans Light"/>
-                </a:rPr>
-                <a:t/>
-              </a:r>
+              <a:endParaRPr/>
             </a:p>
           </p:txBody>
         </p:sp>
         <p:grpSp>
           <p:nvGrpSpPr>
-            <p:cNvPr name="Group 16" id="16"/>
+            <p:cNvPr id="16" name="Group 16"/>
             <p:cNvGrpSpPr/>
             <p:nvPr/>
           </p:nvGrpSpPr>
           <p:grpSpPr>
-            <a:xfrm rot="0">
+            <a:xfrm>
               <a:off x="3659312" y="7487823"/>
               <a:ext cx="2242180" cy="2242180"/>
               <a:chOff x="0" y="0"/>
@@ -4481,12 +4451,12 @@
           </p:grpSpPr>
           <p:sp>
             <p:nvSpPr>
-              <p:cNvPr name="Freeform 17" id="17"/>
+              <p:cNvPr id="17" name="Freeform 17"/>
               <p:cNvSpPr/>
               <p:nvPr/>
             </p:nvSpPr>
             <p:spPr>
-              <a:xfrm flipH="false" flipV="false" rot="0">
+              <a:xfrm>
                 <a:off x="0" y="0"/>
                 <a:ext cx="812800" cy="812800"/>
               </a:xfrm>
@@ -4495,9 +4465,9 @@
                 <a:gdLst/>
                 <a:ahLst/>
                 <a:cxnLst/>
-                <a:rect r="r" b="b" t="t" l="l"/>
+                <a:rect l="l" t="t" r="r" b="b"/>
                 <a:pathLst>
-                  <a:path h="812800" w="812800">
+                  <a:path w="812800" h="812800">
                     <a:moveTo>
                       <a:pt x="406400" y="0"/>
                     </a:moveTo>
@@ -4526,26 +4496,29 @@
                 </a:pathLst>
               </a:custGeom>
               <a:blipFill>
-                <a:blip r:embed="rId3"/>
+                <a:blip r:embed="rId6"/>
                 <a:stretch>
-                  <a:fillRect l="-78303" t="0" r="-78303" b="0"/>
+                  <a:fillRect/>
                 </a:stretch>
               </a:blipFill>
             </p:spPr>
             <p:txBody>
               <a:bodyPr/>
-              <a:p/>
+              <a:lstStyle/>
+              <a:p>
+                <a:endParaRPr/>
+              </a:p>
             </p:txBody>
           </p:sp>
         </p:grpSp>
         <p:sp>
           <p:nvSpPr>
-            <p:cNvPr name="TextBox 18" id="18"/>
-            <p:cNvSpPr txBox="true"/>
+            <p:cNvPr id="18" name="TextBox 18"/>
+            <p:cNvSpPr txBox="1"/>
             <p:nvPr/>
           </p:nvSpPr>
           <p:spPr>
-            <a:xfrm rot="0">
+            <a:xfrm>
               <a:off x="-1450604" y="7905395"/>
               <a:ext cx="4618880" cy="438841"/>
             </a:xfrm>
@@ -4554,7 +4527,7 @@
             </a:prstGeom>
           </p:spPr>
           <p:txBody>
-            <a:bodyPr anchor="t" rtlCol="false" tIns="0" lIns="0" bIns="0" rIns="0">
+            <a:bodyPr lIns="0" tIns="0" rIns="0" bIns="0" rtlCol="0" anchor="t">
               <a:spAutoFit/>
             </a:bodyPr>
             <a:lstStyle/>
@@ -4581,12 +4554,12 @@
         </p:sp>
         <p:sp>
           <p:nvSpPr>
-            <p:cNvPr name="TextBox 19" id="19"/>
-            <p:cNvSpPr txBox="true"/>
+            <p:cNvPr id="19" name="TextBox 19"/>
+            <p:cNvSpPr txBox="1"/>
             <p:nvPr/>
           </p:nvSpPr>
           <p:spPr>
-            <a:xfrm rot="0">
+            <a:xfrm>
               <a:off x="31076" y="8357310"/>
               <a:ext cx="4581599" cy="455581"/>
             </a:xfrm>
@@ -4595,7 +4568,7 @@
             </a:prstGeom>
           </p:spPr>
           <p:txBody>
-            <a:bodyPr anchor="t" rtlCol="false" tIns="0" lIns="0" bIns="0" rIns="0">
+            <a:bodyPr lIns="0" tIns="0" rIns="0" bIns="0" rtlCol="0" anchor="t">
               <a:spAutoFit/>
             </a:bodyPr>
             <a:lstStyle/>
@@ -4605,30 +4578,19 @@
                   <a:spcPts val="2835"/>
                 </a:lnSpc>
               </a:pPr>
-              <a:r>
-                <a:rPr lang="en-US" sz="2025">
-                  <a:solidFill>
-                    <a:srgbClr val="000000"/>
-                  </a:solidFill>
-                  <a:latin typeface="Fira Sans Light"/>
-                  <a:ea typeface="Fira Sans Light"/>
-                  <a:cs typeface="Fira Sans Light"/>
-                  <a:sym typeface="Fira Sans Light"/>
-                </a:rPr>
-                <a:t/>
-              </a:r>
+              <a:endParaRPr/>
             </a:p>
           </p:txBody>
         </p:sp>
       </p:grpSp>
       <p:sp>
         <p:nvSpPr>
-          <p:cNvPr name="TextBox 20" id="20"/>
-          <p:cNvSpPr txBox="true"/>
+          <p:cNvPr id="20" name="TextBox 20"/>
+          <p:cNvSpPr txBox="1"/>
           <p:nvPr/>
         </p:nvSpPr>
         <p:spPr>
-          <a:xfrm rot="0">
+          <a:xfrm>
             <a:off x="365513" y="309041"/>
             <a:ext cx="7051819" cy="1974457"/>
           </a:xfrm>
@@ -4637,7 +4599,7 @@
           </a:prstGeom>
         </p:spPr>
         <p:txBody>
-          <a:bodyPr anchor="t" rtlCol="false" tIns="0" lIns="0" bIns="0" rIns="0">
+          <a:bodyPr lIns="0" tIns="0" rIns="0" bIns="0" rtlCol="0" anchor="t">
             <a:spAutoFit/>
           </a:bodyPr>
           <a:lstStyle/>
@@ -4689,8 +4651,8 @@
 </p:sld>
 </file>
 
-<file path=ppt/slides/slide3.xml><?xml version="1.0" encoding="utf-8"?>
-<p:sld xmlns:a="http://schemas.openxmlformats.org/drawingml/2006/main" xmlns:p="http://schemas.openxmlformats.org/presentationml/2006/main" xmlns:r="http://schemas.openxmlformats.org/officeDocument/2006/relationships">
+<file path=ppt/slides/slide2.xml><?xml version="1.0" encoding="utf-8"?>
+<p:sld xmlns:a="http://schemas.openxmlformats.org/drawingml/2006/main" xmlns:r="http://schemas.openxmlformats.org/officeDocument/2006/relationships" xmlns:p="http://schemas.openxmlformats.org/presentationml/2006/main">
   <p:cSld>
     <p:spTree>
       <p:nvGrpSpPr>
@@ -4698,7 +4660,14 @@
         <p:cNvGrpSpPr/>
         <p:nvPr/>
       </p:nvGrpSpPr>
-      <p:grpSpPr/>
+      <p:grpSpPr>
+        <a:xfrm>
+          <a:off x="0" y="0"/>
+          <a:ext cx="0" cy="0"/>
+          <a:chOff x="0" y="0"/>
+          <a:chExt cx="0" cy="0"/>
+        </a:xfrm>
+      </p:grpSpPr>
       <p:pic>
         <p:nvPicPr>
           <p:cNvPr id="2" name="Picture 1" descr="slide02.png"/>
@@ -4708,7 +4677,56 @@
           <p:nvPr/>
         </p:nvPicPr>
         <p:blipFill>
-          <a:blip r:embed="rId2"/>
+          <a:blip r:embed="rId3"/>
+          <a:stretch>
+            <a:fillRect/>
+          </a:stretch>
+        </p:blipFill>
+        <p:spPr>
+          <a:xfrm>
+            <a:off x="0" y="0"/>
+            <a:ext cx="18288000" cy="10287000"/>
+          </a:xfrm>
+          <a:prstGeom prst="rect">
+            <a:avLst/>
+          </a:prstGeom>
+        </p:spPr>
+      </p:pic>
+    </p:spTree>
+  </p:cSld>
+  <p:clrMapOvr>
+    <a:masterClrMapping/>
+  </p:clrMapOvr>
+</p:sld>
+</file>
+
+<file path=ppt/slides/slide3.xml><?xml version="1.0" encoding="utf-8"?>
+<p:sld xmlns:a="http://schemas.openxmlformats.org/drawingml/2006/main" xmlns:r="http://schemas.openxmlformats.org/officeDocument/2006/relationships" xmlns:p="http://schemas.openxmlformats.org/presentationml/2006/main">
+  <p:cSld>
+    <p:spTree>
+      <p:nvGrpSpPr>
+        <p:cNvPr id="1" name=""/>
+        <p:cNvGrpSpPr/>
+        <p:nvPr/>
+      </p:nvGrpSpPr>
+      <p:grpSpPr>
+        <a:xfrm>
+          <a:off x="0" y="0"/>
+          <a:ext cx="0" cy="0"/>
+          <a:chOff x="0" y="0"/>
+          <a:chExt cx="0" cy="0"/>
+        </a:xfrm>
+      </p:grpSpPr>
+      <p:pic>
+        <p:nvPicPr>
+          <p:cNvPr id="2" name="Picture 1" descr="slide03.png"/>
+          <p:cNvPicPr>
+            <a:picLocks noChangeAspect="1"/>
+          </p:cNvPicPr>
+          <p:nvPr/>
+        </p:nvPicPr>
+        <p:blipFill>
+          <a:blip r:embed="rId3"/>
           <a:stretch>
             <a:fillRect/>
           </a:stretch>
@@ -4732,7 +4750,7 @@
 </file>
 
 <file path=ppt/slides/slide4.xml><?xml version="1.0" encoding="utf-8"?>
-<p:sld xmlns:a="http://schemas.openxmlformats.org/drawingml/2006/main" xmlns:p="http://schemas.openxmlformats.org/presentationml/2006/main" xmlns:r="http://schemas.openxmlformats.org/officeDocument/2006/relationships">
+<p:sld xmlns:a="http://schemas.openxmlformats.org/drawingml/2006/main" xmlns:r="http://schemas.openxmlformats.org/officeDocument/2006/relationships" xmlns:p="http://schemas.openxmlformats.org/presentationml/2006/main">
   <p:cSld>
     <p:spTree>
       <p:nvGrpSpPr>
@@ -4740,17 +4758,24 @@
         <p:cNvGrpSpPr/>
         <p:nvPr/>
       </p:nvGrpSpPr>
-      <p:grpSpPr/>
+      <p:grpSpPr>
+        <a:xfrm>
+          <a:off x="0" y="0"/>
+          <a:ext cx="0" cy="0"/>
+          <a:chOff x="0" y="0"/>
+          <a:chExt cx="0" cy="0"/>
+        </a:xfrm>
+      </p:grpSpPr>
       <p:pic>
         <p:nvPicPr>
-          <p:cNvPr id="2" name="Picture 1" descr="slide03.png"/>
+          <p:cNvPr id="2" name="Picture 1" descr="slide04.png"/>
           <p:cNvPicPr>
             <a:picLocks noChangeAspect="1"/>
           </p:cNvPicPr>
           <p:nvPr/>
         </p:nvPicPr>
         <p:blipFill>
-          <a:blip r:embed="rId2"/>
+          <a:blip r:embed="rId3"/>
           <a:stretch>
             <a:fillRect/>
           </a:stretch>
@@ -4774,7 +4799,7 @@
 </file>
 
 <file path=ppt/slides/slide5.xml><?xml version="1.0" encoding="utf-8"?>
-<p:sld xmlns:a="http://schemas.openxmlformats.org/drawingml/2006/main" xmlns:p="http://schemas.openxmlformats.org/presentationml/2006/main" xmlns:r="http://schemas.openxmlformats.org/officeDocument/2006/relationships">
+<p:sld xmlns:a="http://schemas.openxmlformats.org/drawingml/2006/main" xmlns:r="http://schemas.openxmlformats.org/officeDocument/2006/relationships" xmlns:p="http://schemas.openxmlformats.org/presentationml/2006/main">
   <p:cSld>
     <p:spTree>
       <p:nvGrpSpPr>
@@ -4782,17 +4807,24 @@
         <p:cNvGrpSpPr/>
         <p:nvPr/>
       </p:nvGrpSpPr>
-      <p:grpSpPr/>
+      <p:grpSpPr>
+        <a:xfrm>
+          <a:off x="0" y="0"/>
+          <a:ext cx="0" cy="0"/>
+          <a:chOff x="0" y="0"/>
+          <a:chExt cx="0" cy="0"/>
+        </a:xfrm>
+      </p:grpSpPr>
       <p:pic>
         <p:nvPicPr>
-          <p:cNvPr id="2" name="Picture 1" descr="slide04.png"/>
+          <p:cNvPr id="2" name="Picture 1" descr="slide05.png"/>
           <p:cNvPicPr>
             <a:picLocks noChangeAspect="1"/>
           </p:cNvPicPr>
           <p:nvPr/>
         </p:nvPicPr>
         <p:blipFill>
-          <a:blip r:embed="rId2"/>
+          <a:blip r:embed="rId3"/>
           <a:stretch>
             <a:fillRect/>
           </a:stretch>
@@ -4816,7 +4848,7 @@
 </file>
 
 <file path=ppt/slides/slide6.xml><?xml version="1.0" encoding="utf-8"?>
-<p:sld xmlns:a="http://schemas.openxmlformats.org/drawingml/2006/main" xmlns:p="http://schemas.openxmlformats.org/presentationml/2006/main" xmlns:r="http://schemas.openxmlformats.org/officeDocument/2006/relationships">
+<p:sld xmlns:a="http://schemas.openxmlformats.org/drawingml/2006/main" xmlns:r="http://schemas.openxmlformats.org/officeDocument/2006/relationships" xmlns:p="http://schemas.openxmlformats.org/presentationml/2006/main">
   <p:cSld>
     <p:spTree>
       <p:nvGrpSpPr>
@@ -4824,17 +4856,24 @@
         <p:cNvGrpSpPr/>
         <p:nvPr/>
       </p:nvGrpSpPr>
-      <p:grpSpPr/>
+      <p:grpSpPr>
+        <a:xfrm>
+          <a:off x="0" y="0"/>
+          <a:ext cx="0" cy="0"/>
+          <a:chOff x="0" y="0"/>
+          <a:chExt cx="0" cy="0"/>
+        </a:xfrm>
+      </p:grpSpPr>
       <p:pic>
         <p:nvPicPr>
-          <p:cNvPr id="2" name="Picture 1" descr="slide05.png"/>
+          <p:cNvPr id="2" name="Picture 1" descr="slide06.png"/>
           <p:cNvPicPr>
             <a:picLocks noChangeAspect="1"/>
           </p:cNvPicPr>
           <p:nvPr/>
         </p:nvPicPr>
         <p:blipFill>
-          <a:blip r:embed="rId2"/>
+          <a:blip r:embed="rId3"/>
           <a:stretch>
             <a:fillRect/>
           </a:stretch>
@@ -4858,7 +4897,7 @@
 </file>
 
 <file path=ppt/slides/slide7.xml><?xml version="1.0" encoding="utf-8"?>
-<p:sld xmlns:a="http://schemas.openxmlformats.org/drawingml/2006/main" xmlns:p="http://schemas.openxmlformats.org/presentationml/2006/main" xmlns:r="http://schemas.openxmlformats.org/officeDocument/2006/relationships">
+<p:sld xmlns:a="http://schemas.openxmlformats.org/drawingml/2006/main" xmlns:r="http://schemas.openxmlformats.org/officeDocument/2006/relationships" xmlns:p="http://schemas.openxmlformats.org/presentationml/2006/main">
   <p:cSld>
     <p:spTree>
       <p:nvGrpSpPr>
@@ -4866,17 +4905,24 @@
         <p:cNvGrpSpPr/>
         <p:nvPr/>
       </p:nvGrpSpPr>
-      <p:grpSpPr/>
+      <p:grpSpPr>
+        <a:xfrm>
+          <a:off x="0" y="0"/>
+          <a:ext cx="0" cy="0"/>
+          <a:chOff x="0" y="0"/>
+          <a:chExt cx="0" cy="0"/>
+        </a:xfrm>
+      </p:grpSpPr>
       <p:pic>
         <p:nvPicPr>
-          <p:cNvPr id="2" name="Picture 1" descr="slide06.png"/>
+          <p:cNvPr id="2" name="Picture 1" descr="slide07.png"/>
           <p:cNvPicPr>
             <a:picLocks noChangeAspect="1"/>
           </p:cNvPicPr>
           <p:nvPr/>
         </p:nvPicPr>
         <p:blipFill>
-          <a:blip r:embed="rId2"/>
+          <a:blip r:embed="rId3"/>
           <a:stretch>
             <a:fillRect/>
           </a:stretch>
@@ -4900,7 +4946,7 @@
 </file>
 
 <file path=ppt/slides/slide8.xml><?xml version="1.0" encoding="utf-8"?>
-<p:sld xmlns:a="http://schemas.openxmlformats.org/drawingml/2006/main" xmlns:p="http://schemas.openxmlformats.org/presentationml/2006/main" xmlns:r="http://schemas.openxmlformats.org/officeDocument/2006/relationships">
+<p:sld xmlns:a="http://schemas.openxmlformats.org/drawingml/2006/main" xmlns:r="http://schemas.openxmlformats.org/officeDocument/2006/relationships" xmlns:p="http://schemas.openxmlformats.org/presentationml/2006/main">
   <p:cSld>
     <p:spTree>
       <p:nvGrpSpPr>
@@ -4908,17 +4954,24 @@
         <p:cNvGrpSpPr/>
         <p:nvPr/>
       </p:nvGrpSpPr>
-      <p:grpSpPr/>
+      <p:grpSpPr>
+        <a:xfrm>
+          <a:off x="0" y="0"/>
+          <a:ext cx="0" cy="0"/>
+          <a:chOff x="0" y="0"/>
+          <a:chExt cx="0" cy="0"/>
+        </a:xfrm>
+      </p:grpSpPr>
       <p:pic>
         <p:nvPicPr>
-          <p:cNvPr id="2" name="Picture 1" descr="slide07.png"/>
+          <p:cNvPr id="2" name="Picture 1" descr="slide08.png"/>
           <p:cNvPicPr>
             <a:picLocks noChangeAspect="1"/>
           </p:cNvPicPr>
           <p:nvPr/>
         </p:nvPicPr>
         <p:blipFill>
-          <a:blip r:embed="rId2"/>
+          <a:blip r:embed="rId3"/>
           <a:stretch>
             <a:fillRect/>
           </a:stretch>
@@ -4942,55 +4995,14 @@
 </file>
 
 <file path=ppt/slides/slide9.xml><?xml version="1.0" encoding="utf-8"?>
-<p:sld xmlns:a="http://schemas.openxmlformats.org/drawingml/2006/main" xmlns:p="http://schemas.openxmlformats.org/presentationml/2006/main" xmlns:r="http://schemas.openxmlformats.org/officeDocument/2006/relationships">
-  <p:cSld>
-    <p:spTree>
-      <p:nvGrpSpPr>
-        <p:cNvPr id="1" name=""/>
-        <p:cNvGrpSpPr/>
-        <p:nvPr/>
-      </p:nvGrpSpPr>
-      <p:grpSpPr/>
-      <p:pic>
-        <p:nvPicPr>
-          <p:cNvPr id="2" name="Picture 1" descr="slide08.png"/>
-          <p:cNvPicPr>
-            <a:picLocks noChangeAspect="1"/>
-          </p:cNvPicPr>
-          <p:nvPr/>
-        </p:nvPicPr>
-        <p:blipFill>
-          <a:blip r:embed="rId2"/>
-          <a:stretch>
-            <a:fillRect/>
-          </a:stretch>
-        </p:blipFill>
-        <p:spPr>
-          <a:xfrm>
-            <a:off x="0" y="0"/>
-            <a:ext cx="18288000" cy="10287000"/>
-          </a:xfrm>
-          <a:prstGeom prst="rect">
-            <a:avLst/>
-          </a:prstGeom>
-        </p:spPr>
-      </p:pic>
-    </p:spTree>
-  </p:cSld>
-  <p:clrMapOvr>
-    <a:masterClrMapping/>
-  </p:clrMapOvr>
-</p:sld>
-</file>
-
-<file path=ppt/slides/slide999.xml><?xml version="1.0" encoding="utf-8"?>
-<p:sld xmlns:p="http://schemas.openxmlformats.org/presentationml/2006/main" xmlns:a="http://schemas.openxmlformats.org/drawingml/2006/main" xmlns:r="http://schemas.openxmlformats.org/officeDocument/2006/relationships">
+<p:sld xmlns:a="http://schemas.openxmlformats.org/drawingml/2006/main" xmlns:r="http://schemas.openxmlformats.org/officeDocument/2006/relationships" xmlns:p="http://schemas.openxmlformats.org/presentationml/2006/main">
   <p:cSld>
     <p:bg>
       <p:bgPr>
         <a:solidFill>
           <a:srgbClr val="FE7EB6"/>
         </a:solidFill>
+        <a:effectLst/>
       </p:bgPr>
     </p:bg>
     <p:spTree>
@@ -5009,12 +5021,12 @@
       </p:grpSpPr>
       <p:sp>
         <p:nvSpPr>
-          <p:cNvPr name="Freeform 2" id="2"/>
+          <p:cNvPr id="2" name="Freeform 2"/>
           <p:cNvSpPr/>
           <p:nvPr/>
         </p:nvSpPr>
         <p:spPr>
-          <a:xfrm flipH="false" flipV="false" rot="0">
+          <a:xfrm>
             <a:off x="0" y="0"/>
             <a:ext cx="18288000" cy="10287000"/>
           </a:xfrm>
@@ -5023,9 +5035,9 @@
             <a:gdLst/>
             <a:ahLst/>
             <a:cxnLst/>
-            <a:rect r="r" b="b" t="t" l="l"/>
+            <a:rect l="l" t="t" r="r" b="b"/>
             <a:pathLst>
-              <a:path h="10287000" w="18288000">
+              <a:path w="18288000" h="10287000">
                 <a:moveTo>
                   <a:pt x="0" y="0"/>
                 </a:moveTo>
@@ -5048,23 +5060,26 @@
           <a:blipFill>
             <a:blip r:embed="rId2"/>
             <a:stretch>
-              <a:fillRect l="-223" t="0" r="-223" b="0"/>
+              <a:fillRect l="-223" r="-223"/>
             </a:stretch>
           </a:blipFill>
         </p:spPr>
         <p:txBody>
           <a:bodyPr/>
-          <a:p/>
-        </p:txBody>
-      </p:sp>
-      <p:sp>
-        <p:nvSpPr>
-          <p:cNvPr name="TextBox 3" id="3"/>
-          <p:cNvSpPr txBox="true"/>
+          <a:lstStyle/>
+          <a:p>
+            <a:endParaRPr u="sng"/>
+          </a:p>
+        </p:txBody>
+      </p:sp>
+      <p:sp>
+        <p:nvSpPr>
+          <p:cNvPr id="3" name="TextBox 3"/>
+          <p:cNvSpPr txBox="1"/>
           <p:nvPr/>
         </p:nvSpPr>
         <p:spPr>
-          <a:xfrm rot="0">
+          <a:xfrm>
             <a:off x="4725859" y="1843312"/>
             <a:ext cx="8836282" cy="2210076"/>
           </a:xfrm>
@@ -5073,7 +5088,7 @@
           </a:prstGeom>
         </p:spPr>
         <p:txBody>
-          <a:bodyPr anchor="t" rtlCol="false" tIns="0" lIns="0" bIns="0" rIns="0">
+          <a:bodyPr lIns="0" tIns="0" rIns="0" bIns="0" rtlCol="0" anchor="t">
             <a:spAutoFit/>
           </a:bodyPr>
           <a:lstStyle/>
@@ -5119,12 +5134,12 @@
       </p:sp>
       <p:sp>
         <p:nvSpPr>
-          <p:cNvPr name="TextBox 4" id="4"/>
-          <p:cNvSpPr txBox="true"/>
+          <p:cNvPr id="4" name="TextBox 4"/>
+          <p:cNvSpPr txBox="1"/>
           <p:nvPr/>
         </p:nvSpPr>
         <p:spPr>
-          <a:xfrm rot="0">
+          <a:xfrm>
             <a:off x="5598349" y="5086350"/>
             <a:ext cx="7091302" cy="513456"/>
           </a:xfrm>
@@ -5133,7 +5148,7 @@
           </a:prstGeom>
         </p:spPr>
         <p:txBody>
-          <a:bodyPr anchor="t" rtlCol="false" tIns="0" lIns="0" bIns="0" rIns="0">
+          <a:bodyPr lIns="0" tIns="0" rIns="0" bIns="0" rtlCol="0" anchor="t">
             <a:spAutoFit/>
           </a:bodyPr>
           <a:lstStyle/>
@@ -5158,200 +5173,14 @@
           </a:p>
         </p:txBody>
       </p:sp>
-      <p:grpSp>
-        <p:nvGrpSpPr>
-          <p:cNvPr name="Group 5" id="5"/>
-          <p:cNvGrpSpPr/>
-          <p:nvPr/>
-        </p:nvGrpSpPr>
-        <p:grpSpPr>
-          <a:xfrm rot="0">
-            <a:off x="4725859" y="5981345"/>
-            <a:ext cx="1934062" cy="1934062"/>
-            <a:chOff x="0" y="0"/>
-            <a:chExt cx="6350000" cy="6350000"/>
-          </a:xfrm>
-        </p:grpSpPr>
-        <p:sp>
-          <p:nvSpPr>
-            <p:cNvPr name="Freeform 6" id="6"/>
-            <p:cNvSpPr/>
-            <p:nvPr/>
-          </p:nvSpPr>
-          <p:spPr>
-            <a:xfrm flipH="false" flipV="false" rot="0">
-              <a:off x="585470" y="585470"/>
-              <a:ext cx="5179060" cy="5179060"/>
-            </a:xfrm>
-            <a:custGeom>
-              <a:avLst/>
-              <a:gdLst/>
-              <a:ahLst/>
-              <a:cxnLst/>
-              <a:rect r="r" b="b" t="t" l="l"/>
-              <a:pathLst>
-                <a:path h="5179060" w="5179060">
-                  <a:moveTo>
-                    <a:pt x="0" y="0"/>
-                  </a:moveTo>
-                  <a:lnTo>
-                    <a:pt x="5179060" y="0"/>
-                  </a:lnTo>
-                  <a:lnTo>
-                    <a:pt x="5179060" y="5179060"/>
-                  </a:lnTo>
-                  <a:lnTo>
-                    <a:pt x="0" y="5179060"/>
-                  </a:lnTo>
-                  <a:close/>
-                </a:path>
-              </a:pathLst>
-            </a:custGeom>
-            <a:blipFill>
-              <a:blip r:embed="rId3"/>
-              <a:stretch>
-                <a:fillRect l="-107311" t="-11304" r="-107311" b="-11304"/>
-              </a:stretch>
-            </a:blipFill>
-          </p:spPr>
-          <p:txBody>
-            <a:bodyPr/>
-            <a:p/>
-          </p:txBody>
-        </p:sp>
-      </p:grpSp>
-      <p:grpSp>
-        <p:nvGrpSpPr>
-          <p:cNvPr name="Group 7" id="7"/>
-          <p:cNvGrpSpPr/>
-          <p:nvPr/>
-        </p:nvGrpSpPr>
-        <p:grpSpPr>
-          <a:xfrm rot="0">
-            <a:off x="7023924" y="5981345"/>
-            <a:ext cx="1934062" cy="1934062"/>
-            <a:chOff x="0" y="0"/>
-            <a:chExt cx="6350000" cy="6350000"/>
-          </a:xfrm>
-        </p:grpSpPr>
-        <p:sp>
-          <p:nvSpPr>
-            <p:cNvPr name="Freeform 8" id="8"/>
-            <p:cNvSpPr/>
-            <p:nvPr/>
-          </p:nvSpPr>
-          <p:spPr>
-            <a:xfrm flipH="false" flipV="false" rot="0">
-              <a:off x="585470" y="585470"/>
-              <a:ext cx="5179060" cy="5179060"/>
-            </a:xfrm>
-            <a:custGeom>
-              <a:avLst/>
-              <a:gdLst/>
-              <a:ahLst/>
-              <a:cxnLst/>
-              <a:rect r="r" b="b" t="t" l="l"/>
-              <a:pathLst>
-                <a:path h="5179060" w="5179060">
-                  <a:moveTo>
-                    <a:pt x="0" y="0"/>
-                  </a:moveTo>
-                  <a:lnTo>
-                    <a:pt x="5179060" y="0"/>
-                  </a:lnTo>
-                  <a:lnTo>
-                    <a:pt x="5179060" y="5179060"/>
-                  </a:lnTo>
-                  <a:lnTo>
-                    <a:pt x="0" y="5179060"/>
-                  </a:lnTo>
-                  <a:close/>
-                </a:path>
-              </a:pathLst>
-            </a:custGeom>
-            <a:blipFill>
-              <a:blip r:embed="rId3"/>
-              <a:stretch>
-                <a:fillRect l="-107311" t="-11304" r="-107311" b="-11304"/>
-              </a:stretch>
-            </a:blipFill>
-          </p:spPr>
-          <p:txBody>
-            <a:bodyPr/>
-            <a:p/>
-          </p:txBody>
-        </p:sp>
-      </p:grpSp>
-      <p:grpSp>
-        <p:nvGrpSpPr>
-          <p:cNvPr name="Group 9" id="9"/>
-          <p:cNvGrpSpPr/>
-          <p:nvPr/>
-        </p:nvGrpSpPr>
-        <p:grpSpPr>
-          <a:xfrm rot="0">
-            <a:off x="9319936" y="5981345"/>
-            <a:ext cx="1934062" cy="1934062"/>
-            <a:chOff x="0" y="0"/>
-            <a:chExt cx="6350000" cy="6350000"/>
-          </a:xfrm>
-        </p:grpSpPr>
-        <p:sp>
-          <p:nvSpPr>
-            <p:cNvPr name="Freeform 10" id="10"/>
-            <p:cNvSpPr/>
-            <p:nvPr/>
-          </p:nvSpPr>
-          <p:spPr>
-            <a:xfrm flipH="false" flipV="false" rot="0">
-              <a:off x="585470" y="585470"/>
-              <a:ext cx="5179060" cy="5179060"/>
-            </a:xfrm>
-            <a:custGeom>
-              <a:avLst/>
-              <a:gdLst/>
-              <a:ahLst/>
-              <a:cxnLst/>
-              <a:rect r="r" b="b" t="t" l="l"/>
-              <a:pathLst>
-                <a:path h="5179060" w="5179060">
-                  <a:moveTo>
-                    <a:pt x="0" y="0"/>
-                  </a:moveTo>
-                  <a:lnTo>
-                    <a:pt x="5179060" y="0"/>
-                  </a:lnTo>
-                  <a:lnTo>
-                    <a:pt x="5179060" y="5179060"/>
-                  </a:lnTo>
-                  <a:lnTo>
-                    <a:pt x="0" y="5179060"/>
-                  </a:lnTo>
-                  <a:close/>
-                </a:path>
-              </a:pathLst>
-            </a:custGeom>
-            <a:blipFill>
-              <a:blip r:embed="rId3"/>
-              <a:stretch>
-                <a:fillRect l="-107311" t="-11304" r="-107311" b="-11304"/>
-              </a:stretch>
-            </a:blipFill>
-          </p:spPr>
-          <p:txBody>
-            <a:bodyPr/>
-            <a:p/>
-          </p:txBody>
-        </p:sp>
-      </p:grpSp>
-      <p:sp>
-        <p:nvSpPr>
-          <p:cNvPr name="Freeform 11" id="11"/>
+      <p:sp>
+        <p:nvSpPr>
+          <p:cNvPr id="11" name="Freeform 11"/>
           <p:cNvSpPr/>
           <p:nvPr/>
         </p:nvSpPr>
         <p:spPr>
-          <a:xfrm flipH="false" flipV="false" rot="0">
+          <a:xfrm>
             <a:off x="286651" y="9357090"/>
             <a:ext cx="2972682" cy="713444"/>
           </a:xfrm>
@@ -5360,9 +5189,9 @@
             <a:gdLst/>
             <a:ahLst/>
             <a:cxnLst/>
-            <a:rect r="r" b="b" t="t" l="l"/>
+            <a:rect l="l" t="t" r="r" b="b"/>
             <a:pathLst>
-              <a:path h="713444" w="2972682">
+              <a:path w="2972682" h="713444">
                 <a:moveTo>
                   <a:pt x="0" y="0"/>
                 </a:moveTo>
@@ -5383,79 +5212,288 @@
             </a:pathLst>
           </a:custGeom>
           <a:blipFill>
-            <a:blip r:embed="rId4"/>
+            <a:blip r:embed="rId3"/>
             <a:stretch>
-              <a:fillRect l="0" t="0" r="0" b="0"/>
+              <a:fillRect/>
             </a:stretch>
           </a:blipFill>
         </p:spPr>
         <p:txBody>
           <a:bodyPr/>
-          <a:p/>
-        </p:txBody>
-      </p:sp>
-      <p:grpSp>
-        <p:nvGrpSpPr>
-          <p:cNvPr name="Group 12" id="12"/>
-          <p:cNvGrpSpPr/>
+          <a:lstStyle/>
+          <a:p>
+            <a:endParaRPr/>
+          </a:p>
+        </p:txBody>
+      </p:sp>
+      <p:sp>
+        <p:nvSpPr>
+          <p:cNvPr id="17" name="Freeform 5">
+            <a:extLst>
+              <a:ext uri="{FF2B5EF4-FFF2-40B4-BE49-F238E27FC236}">
+                <a16:creationId xmlns:a16="http://schemas.microsoft.com/office/drawing/2014/main" id="{2D9EC144-8D93-9C0E-9123-6BD3B443F7AA}"/>
+              </a:ext>
+            </a:extLst>
+          </p:cNvPr>
+          <p:cNvSpPr/>
           <p:nvPr/>
-        </p:nvGrpSpPr>
-        <p:grpSpPr>
-          <a:xfrm rot="0">
-            <a:off x="11615948" y="5981345"/>
-            <a:ext cx="1934062" cy="1934062"/>
-            <a:chOff x="0" y="0"/>
-            <a:chExt cx="6350000" cy="6350000"/>
+        </p:nvSpPr>
+        <p:spPr>
+          <a:xfrm>
+            <a:off x="4419600" y="5896700"/>
+            <a:ext cx="1681635" cy="1681635"/>
           </a:xfrm>
-        </p:grpSpPr>
-        <p:sp>
-          <p:nvSpPr>
-            <p:cNvPr name="Freeform 13" id="13"/>
-            <p:cNvSpPr/>
-            <p:nvPr/>
-          </p:nvSpPr>
-          <p:spPr>
-            <a:xfrm flipH="false" flipV="false" rot="0">
-              <a:off x="585470" y="585470"/>
-              <a:ext cx="5179060" cy="5179060"/>
-            </a:xfrm>
-            <a:custGeom>
-              <a:avLst/>
-              <a:gdLst/>
-              <a:ahLst/>
-              <a:cxnLst/>
-              <a:rect r="r" b="b" t="t" l="l"/>
-              <a:pathLst>
-                <a:path h="5179060" w="5179060">
-                  <a:moveTo>
-                    <a:pt x="0" y="0"/>
-                  </a:moveTo>
-                  <a:lnTo>
-                    <a:pt x="5179060" y="0"/>
-                  </a:lnTo>
-                  <a:lnTo>
-                    <a:pt x="5179060" y="5179060"/>
-                  </a:lnTo>
-                  <a:lnTo>
-                    <a:pt x="0" y="5179060"/>
-                  </a:lnTo>
-                  <a:close/>
-                </a:path>
-              </a:pathLst>
-            </a:custGeom>
-            <a:blipFill>
-              <a:blip r:embed="rId3"/>
-              <a:stretch>
-                <a:fillRect l="-107311" t="-11304" r="-107311" b="-11304"/>
-              </a:stretch>
-            </a:blipFill>
-          </p:spPr>
-          <p:txBody>
-            <a:bodyPr/>
-            <a:p/>
-          </p:txBody>
-        </p:sp>
-      </p:grpSp>
+          <a:custGeom>
+            <a:avLst/>
+            <a:gdLst/>
+            <a:ahLst/>
+            <a:cxnLst/>
+            <a:rect l="l" t="t" r="r" b="b"/>
+            <a:pathLst>
+              <a:path w="812800" h="812800">
+                <a:moveTo>
+                  <a:pt x="406400" y="0"/>
+                </a:moveTo>
+                <a:cubicBezTo>
+                  <a:pt x="181951" y="0"/>
+                  <a:pt x="0" y="181951"/>
+                  <a:pt x="0" y="406400"/>
+                </a:cubicBezTo>
+                <a:cubicBezTo>
+                  <a:pt x="0" y="630849"/>
+                  <a:pt x="181951" y="812800"/>
+                  <a:pt x="406400" y="812800"/>
+                </a:cubicBezTo>
+                <a:cubicBezTo>
+                  <a:pt x="630849" y="812800"/>
+                  <a:pt x="812800" y="630849"/>
+                  <a:pt x="812800" y="406400"/>
+                </a:cubicBezTo>
+                <a:cubicBezTo>
+                  <a:pt x="812800" y="181951"/>
+                  <a:pt x="630849" y="0"/>
+                  <a:pt x="406400" y="0"/>
+                </a:cubicBezTo>
+                <a:close/>
+              </a:path>
+            </a:pathLst>
+          </a:custGeom>
+          <a:blipFill>
+            <a:blip r:embed="rId4"/>
+            <a:stretch>
+              <a:fillRect/>
+            </a:stretch>
+          </a:blipFill>
+        </p:spPr>
+        <p:txBody>
+          <a:bodyPr/>
+          <a:lstStyle/>
+          <a:p>
+            <a:endParaRPr dirty="0"/>
+          </a:p>
+        </p:txBody>
+      </p:sp>
+      <p:sp>
+        <p:nvSpPr>
+          <p:cNvPr id="19" name="Freeform 9">
+            <a:extLst>
+              <a:ext uri="{FF2B5EF4-FFF2-40B4-BE49-F238E27FC236}">
+                <a16:creationId xmlns:a16="http://schemas.microsoft.com/office/drawing/2014/main" id="{9B1AE247-491D-1B94-EDC1-D932BDD86601}"/>
+              </a:ext>
+            </a:extLst>
+          </p:cNvPr>
+          <p:cNvSpPr/>
+          <p:nvPr/>
+        </p:nvSpPr>
+        <p:spPr>
+          <a:xfrm>
+            <a:off x="6781800" y="5896700"/>
+            <a:ext cx="1681635" cy="1681635"/>
+          </a:xfrm>
+          <a:custGeom>
+            <a:avLst/>
+            <a:gdLst/>
+            <a:ahLst/>
+            <a:cxnLst/>
+            <a:rect l="l" t="t" r="r" b="b"/>
+            <a:pathLst>
+              <a:path w="812800" h="812800">
+                <a:moveTo>
+                  <a:pt x="406400" y="0"/>
+                </a:moveTo>
+                <a:cubicBezTo>
+                  <a:pt x="181951" y="0"/>
+                  <a:pt x="0" y="181951"/>
+                  <a:pt x="0" y="406400"/>
+                </a:cubicBezTo>
+                <a:cubicBezTo>
+                  <a:pt x="0" y="630849"/>
+                  <a:pt x="181951" y="812800"/>
+                  <a:pt x="406400" y="812800"/>
+                </a:cubicBezTo>
+                <a:cubicBezTo>
+                  <a:pt x="630849" y="812800"/>
+                  <a:pt x="812800" y="630849"/>
+                  <a:pt x="812800" y="406400"/>
+                </a:cubicBezTo>
+                <a:cubicBezTo>
+                  <a:pt x="812800" y="181951"/>
+                  <a:pt x="630849" y="0"/>
+                  <a:pt x="406400" y="0"/>
+                </a:cubicBezTo>
+                <a:close/>
+              </a:path>
+            </a:pathLst>
+          </a:custGeom>
+          <a:blipFill>
+            <a:blip r:embed="rId5"/>
+            <a:stretch>
+              <a:fillRect/>
+            </a:stretch>
+          </a:blipFill>
+        </p:spPr>
+        <p:txBody>
+          <a:bodyPr/>
+          <a:lstStyle/>
+          <a:p>
+            <a:endParaRPr/>
+          </a:p>
+        </p:txBody>
+      </p:sp>
+      <p:sp>
+        <p:nvSpPr>
+          <p:cNvPr id="21" name="Freeform 13">
+            <a:extLst>
+              <a:ext uri="{FF2B5EF4-FFF2-40B4-BE49-F238E27FC236}">
+                <a16:creationId xmlns:a16="http://schemas.microsoft.com/office/drawing/2014/main" id="{25D9BF61-93AA-59A6-B52D-4B0616CFA234}"/>
+              </a:ext>
+            </a:extLst>
+          </p:cNvPr>
+          <p:cNvSpPr/>
+          <p:nvPr/>
+        </p:nvSpPr>
+        <p:spPr>
+          <a:xfrm>
+            <a:off x="9597536" y="5896700"/>
+            <a:ext cx="1681635" cy="1681635"/>
+          </a:xfrm>
+          <a:custGeom>
+            <a:avLst/>
+            <a:gdLst/>
+            <a:ahLst/>
+            <a:cxnLst/>
+            <a:rect l="l" t="t" r="r" b="b"/>
+            <a:pathLst>
+              <a:path w="812800" h="812800">
+                <a:moveTo>
+                  <a:pt x="406400" y="0"/>
+                </a:moveTo>
+                <a:cubicBezTo>
+                  <a:pt x="181951" y="0"/>
+                  <a:pt x="0" y="181951"/>
+                  <a:pt x="0" y="406400"/>
+                </a:cubicBezTo>
+                <a:cubicBezTo>
+                  <a:pt x="0" y="630849"/>
+                  <a:pt x="181951" y="812800"/>
+                  <a:pt x="406400" y="812800"/>
+                </a:cubicBezTo>
+                <a:cubicBezTo>
+                  <a:pt x="630849" y="812800"/>
+                  <a:pt x="812800" y="630849"/>
+                  <a:pt x="812800" y="406400"/>
+                </a:cubicBezTo>
+                <a:cubicBezTo>
+                  <a:pt x="812800" y="181951"/>
+                  <a:pt x="630849" y="0"/>
+                  <a:pt x="406400" y="0"/>
+                </a:cubicBezTo>
+                <a:close/>
+              </a:path>
+            </a:pathLst>
+          </a:custGeom>
+          <a:blipFill>
+            <a:blip r:embed="rId6"/>
+            <a:stretch>
+              <a:fillRect/>
+            </a:stretch>
+          </a:blipFill>
+        </p:spPr>
+        <p:txBody>
+          <a:bodyPr/>
+          <a:lstStyle/>
+          <a:p>
+            <a:endParaRPr/>
+          </a:p>
+        </p:txBody>
+      </p:sp>
+      <p:sp>
+        <p:nvSpPr>
+          <p:cNvPr id="23" name="Freeform 17">
+            <a:extLst>
+              <a:ext uri="{FF2B5EF4-FFF2-40B4-BE49-F238E27FC236}">
+                <a16:creationId xmlns:a16="http://schemas.microsoft.com/office/drawing/2014/main" id="{64E8D977-EDA8-39A4-661C-04F99FEB138E}"/>
+              </a:ext>
+            </a:extLst>
+          </p:cNvPr>
+          <p:cNvSpPr/>
+          <p:nvPr/>
+        </p:nvSpPr>
+        <p:spPr>
+          <a:xfrm>
+            <a:off x="12161365" y="5896700"/>
+            <a:ext cx="1681635" cy="1681635"/>
+          </a:xfrm>
+          <a:custGeom>
+            <a:avLst/>
+            <a:gdLst/>
+            <a:ahLst/>
+            <a:cxnLst/>
+            <a:rect l="l" t="t" r="r" b="b"/>
+            <a:pathLst>
+              <a:path w="812800" h="812800">
+                <a:moveTo>
+                  <a:pt x="406400" y="0"/>
+                </a:moveTo>
+                <a:cubicBezTo>
+                  <a:pt x="181951" y="0"/>
+                  <a:pt x="0" y="181951"/>
+                  <a:pt x="0" y="406400"/>
+                </a:cubicBezTo>
+                <a:cubicBezTo>
+                  <a:pt x="0" y="630849"/>
+                  <a:pt x="181951" y="812800"/>
+                  <a:pt x="406400" y="812800"/>
+                </a:cubicBezTo>
+                <a:cubicBezTo>
+                  <a:pt x="630849" y="812800"/>
+                  <a:pt x="812800" y="630849"/>
+                  <a:pt x="812800" y="406400"/>
+                </a:cubicBezTo>
+                <a:cubicBezTo>
+                  <a:pt x="812800" y="181951"/>
+                  <a:pt x="630849" y="0"/>
+                  <a:pt x="406400" y="0"/>
+                </a:cubicBezTo>
+                <a:close/>
+              </a:path>
+            </a:pathLst>
+          </a:custGeom>
+          <a:blipFill>
+            <a:blip r:embed="rId7"/>
+            <a:stretch>
+              <a:fillRect/>
+            </a:stretch>
+          </a:blipFill>
+        </p:spPr>
+        <p:txBody>
+          <a:bodyPr/>
+          <a:lstStyle/>
+          <a:p>
+            <a:endParaRPr dirty="0"/>
+          </a:p>
+        </p:txBody>
+      </p:sp>
     </p:spTree>
   </p:cSld>
   <p:clrMapOvr>
@@ -5748,7 +5786,7 @@
 </file>
 
 <file path=ppt/theme/theme2.xml><?xml version="1.0" encoding="utf-8"?>
-<a:theme xmlns:a="http://schemas.openxmlformats.org/drawingml/2006/main" name="Office Theme">
+<a:theme xmlns:a="http://schemas.openxmlformats.org/drawingml/2006/main" name="Tema de Office">
   <a:themeElements>
     <a:clrScheme name="Office">
       <a:dk1>
@@ -5758,44 +5796,44 @@
         <a:sysClr val="window" lastClr="FFFFFF"/>
       </a:lt1>
       <a:dk2>
-        <a:srgbClr val="1F497D"/>
+        <a:srgbClr val="0E2841"/>
       </a:dk2>
       <a:lt2>
-        <a:srgbClr val="EEECE1"/>
+        <a:srgbClr val="E8E8E8"/>
       </a:lt2>
       <a:accent1>
-        <a:srgbClr val="4F81BD"/>
+        <a:srgbClr val="156082"/>
       </a:accent1>
       <a:accent2>
-        <a:srgbClr val="C0504D"/>
+        <a:srgbClr val="E97132"/>
       </a:accent2>
       <a:accent3>
-        <a:srgbClr val="9BBB59"/>
+        <a:srgbClr val="196B24"/>
       </a:accent3>
       <a:accent4>
-        <a:srgbClr val="8064A2"/>
+        <a:srgbClr val="0F9ED5"/>
       </a:accent4>
       <a:accent5>
-        <a:srgbClr val="4BACC6"/>
+        <a:srgbClr val="A02B93"/>
       </a:accent5>
       <a:accent6>
-        <a:srgbClr val="F79646"/>
+        <a:srgbClr val="4EA72E"/>
       </a:accent6>
       <a:hlink>
-        <a:srgbClr val="0000FF"/>
+        <a:srgbClr val="467886"/>
       </a:hlink>
       <a:folHlink>
-        <a:srgbClr val="800080"/>
+        <a:srgbClr val="96607D"/>
       </a:folHlink>
     </a:clrScheme>
     <a:fontScheme name="Office">
       <a:majorFont>
-        <a:latin typeface="Calibri"/>
+        <a:latin typeface="Aptos Display" panose="02110004020202020204"/>
         <a:ea typeface=""/>
         <a:cs typeface=""/>
-        <a:font script="Jpan" typeface="ＭＳ Ｐゴシック"/>
+        <a:font script="Jpan" typeface="游ゴシック Light"/>
         <a:font script="Hang" typeface="맑은 고딕"/>
-        <a:font script="Hans" typeface="宋体"/>
+        <a:font script="Hans" typeface="等线 Light"/>
         <a:font script="Hant" typeface="新細明體"/>
         <a:font script="Arab" typeface="Times New Roman"/>
         <a:font script="Hebr" typeface="Times New Roman"/>
@@ -5823,14 +5861,31 @@
         <a:font script="Viet" typeface="Times New Roman"/>
         <a:font script="Uigh" typeface="Microsoft Uighur"/>
         <a:font script="Geor" typeface="Sylfaen"/>
+        <a:font script="Armn" typeface="Arial"/>
+        <a:font script="Bugi" typeface="Leelawadee UI"/>
+        <a:font script="Bopo" typeface="Microsoft JhengHei"/>
+        <a:font script="Java" typeface="Javanese Text"/>
+        <a:font script="Lisu" typeface="Segoe UI"/>
+        <a:font script="Mymr" typeface="Myanmar Text"/>
+        <a:font script="Nkoo" typeface="Ebrima"/>
+        <a:font script="Olck" typeface="Nirmala UI"/>
+        <a:font script="Osma" typeface="Ebrima"/>
+        <a:font script="Phag" typeface="Phagspa"/>
+        <a:font script="Syrn" typeface="Estrangelo Edessa"/>
+        <a:font script="Syrj" typeface="Estrangelo Edessa"/>
+        <a:font script="Syre" typeface="Estrangelo Edessa"/>
+        <a:font script="Sora" typeface="Nirmala UI"/>
+        <a:font script="Tale" typeface="Microsoft Tai Le"/>
+        <a:font script="Talu" typeface="Microsoft New Tai Lue"/>
+        <a:font script="Tfng" typeface="Ebrima"/>
       </a:majorFont>
       <a:minorFont>
-        <a:latin typeface="Calibri"/>
+        <a:latin typeface="Aptos" panose="02110004020202020204"/>
         <a:ea typeface=""/>
         <a:cs typeface=""/>
-        <a:font script="Jpan" typeface="ＭＳ Ｐゴシック"/>
+        <a:font script="Jpan" typeface="游ゴシック"/>
         <a:font script="Hang" typeface="맑은 고딕"/>
-        <a:font script="Hans" typeface="宋体"/>
+        <a:font script="Hans" typeface="等线"/>
         <a:font script="Hant" typeface="新細明體"/>
         <a:font script="Arab" typeface="Arial"/>
         <a:font script="Hebr" typeface="Arial"/>
@@ -5858,6 +5913,23 @@
         <a:font script="Viet" typeface="Arial"/>
         <a:font script="Uigh" typeface="Microsoft Uighur"/>
         <a:font script="Geor" typeface="Sylfaen"/>
+        <a:font script="Armn" typeface="Arial"/>
+        <a:font script="Bugi" typeface="Leelawadee UI"/>
+        <a:font script="Bopo" typeface="Microsoft JhengHei"/>
+        <a:font script="Java" typeface="Javanese Text"/>
+        <a:font script="Lisu" typeface="Segoe UI"/>
+        <a:font script="Mymr" typeface="Myanmar Text"/>
+        <a:font script="Nkoo" typeface="Ebrima"/>
+        <a:font script="Olck" typeface="Nirmala UI"/>
+        <a:font script="Osma" typeface="Ebrima"/>
+        <a:font script="Phag" typeface="Phagspa"/>
+        <a:font script="Syrn" typeface="Estrangelo Edessa"/>
+        <a:font script="Syrj" typeface="Estrangelo Edessa"/>
+        <a:font script="Syre" typeface="Estrangelo Edessa"/>
+        <a:font script="Sora" typeface="Nirmala UI"/>
+        <a:font script="Tale" typeface="Microsoft Tai Le"/>
+        <a:font script="Talu" typeface="Microsoft New Tai Lue"/>
+        <a:font script="Tfng" typeface="Ebrima"/>
       </a:minorFont>
     </a:fontScheme>
     <a:fmtScheme name="Office">
@@ -5869,180 +5941,136 @@
           <a:gsLst>
             <a:gs pos="0">
               <a:schemeClr val="phClr">
-                <a:tint val="50000"/>
-                <a:satMod val="300000"/>
+                <a:lumMod val="110000"/>
+                <a:satMod val="105000"/>
+                <a:tint val="67000"/>
               </a:schemeClr>
             </a:gs>
-            <a:gs pos="35000">
+            <a:gs pos="50000">
               <a:schemeClr val="phClr">
-                <a:tint val="37000"/>
-                <a:satMod val="300000"/>
+                <a:lumMod val="105000"/>
+                <a:satMod val="103000"/>
+                <a:tint val="73000"/>
               </a:schemeClr>
             </a:gs>
             <a:gs pos="100000">
               <a:schemeClr val="phClr">
-                <a:tint val="15000"/>
-                <a:satMod val="350000"/>
+                <a:lumMod val="105000"/>
+                <a:satMod val="109000"/>
+                <a:tint val="81000"/>
               </a:schemeClr>
             </a:gs>
           </a:gsLst>
-          <a:lin ang="16200000" scaled="1"/>
+          <a:lin ang="5400000" scaled="0"/>
         </a:gradFill>
         <a:gradFill rotWithShape="1">
           <a:gsLst>
             <a:gs pos="0">
               <a:schemeClr val="phClr">
-                <a:tint val="100000"/>
+                <a:satMod val="103000"/>
+                <a:lumMod val="102000"/>
+                <a:tint val="94000"/>
+              </a:schemeClr>
+            </a:gs>
+            <a:gs pos="50000">
+              <a:schemeClr val="phClr">
+                <a:satMod val="110000"/>
+                <a:lumMod val="100000"/>
                 <a:shade val="100000"/>
-                <a:satMod val="130000"/>
               </a:schemeClr>
             </a:gs>
             <a:gs pos="100000">
               <a:schemeClr val="phClr">
-                <a:tint val="50000"/>
-                <a:shade val="100000"/>
-                <a:satMod val="350000"/>
+                <a:lumMod val="99000"/>
+                <a:satMod val="120000"/>
+                <a:shade val="78000"/>
               </a:schemeClr>
             </a:gs>
           </a:gsLst>
-          <a:lin ang="16200000" scaled="0"/>
+          <a:lin ang="5400000" scaled="0"/>
         </a:gradFill>
       </a:fillStyleLst>
       <a:lnStyleLst>
-        <a:ln w="9525" cap="flat" cmpd="sng" algn="ctr">
+        <a:ln w="12700" cap="flat" cmpd="sng" algn="ctr">
           <a:solidFill>
-            <a:schemeClr val="phClr">
-              <a:shade val="95000"/>
-              <a:satMod val="105000"/>
-            </a:schemeClr>
+            <a:schemeClr val="phClr"/>
           </a:solidFill>
           <a:prstDash val="solid"/>
+          <a:miter lim="800000"/>
+        </a:ln>
+        <a:ln w="19050" cap="flat" cmpd="sng" algn="ctr">
+          <a:solidFill>
+            <a:schemeClr val="phClr"/>
+          </a:solidFill>
+          <a:prstDash val="solid"/>
+          <a:miter lim="800000"/>
         </a:ln>
         <a:ln w="25400" cap="flat" cmpd="sng" algn="ctr">
           <a:solidFill>
             <a:schemeClr val="phClr"/>
           </a:solidFill>
           <a:prstDash val="solid"/>
-        </a:ln>
-        <a:ln w="38100" cap="flat" cmpd="sng" algn="ctr">
-          <a:solidFill>
-            <a:schemeClr val="phClr"/>
-          </a:solidFill>
-          <a:prstDash val="solid"/>
+          <a:miter lim="800000"/>
         </a:ln>
       </a:lnStyleLst>
       <a:effectStyleLst>
         <a:effectStyle>
+          <a:effectLst/>
+        </a:effectStyle>
+        <a:effectStyle>
+          <a:effectLst/>
+        </a:effectStyle>
+        <a:effectStyle>
           <a:effectLst>
-            <a:outerShdw blurRad="40000" dist="20000" dir="5400000" rotWithShape="0">
+            <a:outerShdw blurRad="57150" dist="19050" dir="5400000" algn="ctr" rotWithShape="0">
               <a:srgbClr val="000000">
-                <a:alpha val="38000"/>
+                <a:alpha val="63000"/>
               </a:srgbClr>
             </a:outerShdw>
           </a:effectLst>
-        </a:effectStyle>
-        <a:effectStyle>
-          <a:effectLst>
-            <a:outerShdw blurRad="40000" dist="23000" dir="5400000" rotWithShape="0">
-              <a:srgbClr val="000000">
-                <a:alpha val="35000"/>
-              </a:srgbClr>
-            </a:outerShdw>
-          </a:effectLst>
-        </a:effectStyle>
-        <a:effectStyle>
-          <a:effectLst>
-            <a:outerShdw blurRad="40000" dist="23000" dir="5400000" rotWithShape="0">
-              <a:srgbClr val="000000">
-                <a:alpha val="35000"/>
-              </a:srgbClr>
-            </a:outerShdw>
-          </a:effectLst>
-          <a:scene3d>
-            <a:camera prst="orthographicFront">
-              <a:rot lat="0" lon="0" rev="0"/>
-            </a:camera>
-            <a:lightRig rig="threePt" dir="t">
-              <a:rot lat="0" lon="0" rev="1200000"/>
-            </a:lightRig>
-          </a:scene3d>
-          <a:sp3d>
-            <a:bevelT w="63500" h="25400"/>
-          </a:sp3d>
         </a:effectStyle>
       </a:effectStyleLst>
       <a:bgFillStyleLst>
         <a:solidFill>
           <a:schemeClr val="phClr"/>
         </a:solidFill>
+        <a:solidFill>
+          <a:schemeClr val="phClr">
+            <a:tint val="95000"/>
+            <a:satMod val="170000"/>
+          </a:schemeClr>
+        </a:solidFill>
         <a:gradFill rotWithShape="1">
           <a:gsLst>
             <a:gs pos="0">
               <a:schemeClr val="phClr">
-                <a:tint val="40000"/>
-                <a:satMod val="350000"/>
+                <a:tint val="93000"/>
+                <a:satMod val="150000"/>
+                <a:shade val="98000"/>
+                <a:lumMod val="102000"/>
               </a:schemeClr>
             </a:gs>
-            <a:gs pos="40000">
+            <a:gs pos="50000">
               <a:schemeClr val="phClr">
-                <a:tint val="45000"/>
-                <a:shade val="99000"/>
-                <a:satMod val="350000"/>
+                <a:tint val="98000"/>
+                <a:satMod val="130000"/>
+                <a:shade val="90000"/>
+                <a:lumMod val="103000"/>
               </a:schemeClr>
             </a:gs>
             <a:gs pos="100000">
               <a:schemeClr val="phClr">
-                <a:shade val="20000"/>
-                <a:satMod val="255000"/>
+                <a:shade val="63000"/>
+                <a:satMod val="120000"/>
               </a:schemeClr>
             </a:gs>
           </a:gsLst>
-          <a:path path="circle">
-            <a:fillToRect l="50000" t="-80000" r="50000" b="180000"/>
-          </a:path>
-        </a:gradFill>
-        <a:gradFill rotWithShape="1">
-          <a:gsLst>
-            <a:gs pos="0">
-              <a:schemeClr val="phClr">
-                <a:tint val="80000"/>
-                <a:satMod val="300000"/>
-              </a:schemeClr>
-            </a:gs>
-            <a:gs pos="100000">
-              <a:schemeClr val="phClr">
-                <a:shade val="30000"/>
-                <a:satMod val="200000"/>
-              </a:schemeClr>
-            </a:gs>
-          </a:gsLst>
-          <a:path path="circle">
-            <a:fillToRect l="50000" t="50000" r="50000" b="50000"/>
-          </a:path>
+          <a:lin ang="5400000" scaled="0"/>
         </a:gradFill>
       </a:bgFillStyleLst>
     </a:fmtScheme>
   </a:themeElements>
   <a:objectDefaults>
-    <a:spDef>
-      <a:spPr/>
-      <a:bodyPr/>
-      <a:lstStyle/>
-      <a:style>
-        <a:lnRef idx="1">
-          <a:schemeClr val="accent1"/>
-        </a:lnRef>
-        <a:fillRef idx="3">
-          <a:schemeClr val="accent1"/>
-        </a:fillRef>
-        <a:effectRef idx="2">
-          <a:schemeClr val="accent1"/>
-        </a:effectRef>
-        <a:fontRef idx="minor">
-          <a:schemeClr val="lt1"/>
-        </a:fontRef>
-      </a:style>
-    </a:spDef>
     <a:lnDef>
       <a:spPr/>
       <a:bodyPr/>
@@ -6064,5 +6092,10 @@
     </a:lnDef>
   </a:objectDefaults>
   <a:extraClrSchemeLst/>
+  <a:extLst>
+    <a:ext uri="{05A4C25C-085E-4340-85A3-A5531E510DB2}">
+      <thm15:themeFamily xmlns:thm15="http://schemas.microsoft.com/office/thememl/2012/main" name="Office Theme" id="{2E142A2C-CD16-42D6-873A-C26D2A0506FA}" vid="{1BDDFF52-6CD6-40A5-AB3C-68EB2F1E4D0A}"/>
+    </a:ext>
+  </a:extLst>
 </a:theme>
 </file>
</xml_diff>